<commit_message>
updated ppt for the 9 studio tiles
</commit_message>
<xml_diff>
--- a/decks/beyond_the_demo.pptx
+++ b/decks/beyond_the_demo.pptx
@@ -10,9 +10,10 @@
     <p:sldId id="258" r:id="rId4"/>
     <p:sldId id="259" r:id="rId5"/>
     <p:sldId id="260" r:id="rId6"/>
+    <p:sldId id="261" r:id="rId7"/>
   </p:sldIdLst>
   <p:notesMasterIdLst>
-    <p:notesMasterId r:id="rId7"/>
+    <p:notesMasterId r:id="rId8"/>
   </p:notesMasterIdLst>
   <p:sldSz cx="9144000" cy="5143500"/>
   <p:notesSz cx="5143500" cy="9144000"/>
@@ -688,10 +689,10 @@
           <a:p>
             <a:r>
               <a:rPr lang="en-US" dirty="0"/>
-              <a:t>DELIVERY: Same as the previous slide, read a couple out loud, then open the floor using the 'Your turn' card.
-SAY: Notice these aren't about the AI writing code from scratch and walking away. They're about removing setup friction so the work that WAS worth doing becomes easy enough to actually do.
-ASK THE CLASS: Raise your hand if you've ever put off analyzing a dataset because setting up the environment felt like a bigger job than the analysis itself.
-ASK THE CLASS: For the teaching example, has anyone here been a student or instructor where 'it works on my machine' actually blocked a class? What happened?</a:t>
+              <a:t>DELIVERY: Quick, this is a map of the panel, not a feature-by-feature demo.
+SAY: Today we used two of these nine, Audio Overview and Quiz. The other seven turn the same grounded sources into a table, a diagram, a written report, a visual summary, a deck, a video, or study cards. Same sources every time, just a different shape on the way out.
+ASK THE CLASS: Which of these seven would actually save you time in your own work? A data table with citations? A report you can hand to a manager?
+DO NOT: demo any of the untested seven live. If someone asks to see one, it's fine to open it, but frame it as 'let's find out together' rather than a rehearsed step.</a:t>
             </a:r>
             <a:endParaRPr lang="en-US" dirty="0"/>
           </a:p>
@@ -779,9 +780,10 @@
           <a:p>
             <a:r>
               <a:rPr lang="en-US" dirty="0"/>
-              <a:t>DELIVERY: Slow down here, this is the one idea you want people to leave with.
-SAY: Every example on the last two slides reduces to one of these two moves. If you forget every specific use case by tomorrow, keep these two: ground your answer in sources you can check, and rent the compute instead of owning it.
-ASK THE CLASS: Of the two, which one solves a bigger problem for YOUR work right now? Ask for a show of hands, grounded answers vs. disposable compute.</a:t>
+              <a:t>DELIVERY: Same as the previous slide, read a couple out loud, then open the floor using the 'Your turn' card.
+SAY: Notice these aren't about the AI writing code from scratch and walking away. They're about removing setup friction so the work that WAS worth doing becomes easy enough to actually do.
+ASK THE CLASS: Raise your hand if you've ever put off analyzing a dataset because setting up the environment felt like a bigger job than the analysis itself.
+ASK THE CLASS: For the teaching example, has anyone here been a student or instructor where 'it works on my machine' actually blocked a class? What happened?</a:t>
             </a:r>
             <a:endParaRPr lang="en-US" dirty="0"/>
           </a:p>
@@ -869,10 +871,9 @@
           <a:p>
             <a:r>
               <a:rPr lang="en-US" dirty="0"/>
-              <a:t>DELIVERY: This is a timed pair-share, not a lecture slide. Actually set a 2-minute timer if you have one.
-SAY: Turn to the person next to you. You've each got a task from the start of this section. Two minutes: pick a tool for it, name the first document or dataset you'd load, and say how you'd check the answer before trusting it.
-AFTER 2 MINUTES: Cold-call two or three pairs. Push back gently if someone picks a tool that doesn't fit, e.g., 'that sounds like a live-data question, would grounding in a static doc actually help there?'
-TRANSITION: Close by returning to the two ideas from the previous slide.</a:t>
+              <a:t>DELIVERY: Slow down here, this is the one idea you want people to leave with.
+SAY: Every example on the last two slides reduces to one of these two moves. If you forget every specific use case by tomorrow, keep these two: ground your answer in sources you can check, and rent the compute instead of owning it.
+ASK THE CLASS: Of the two, which one solves a bigger problem for YOUR work right now? Ask for a show of hands, grounded answers vs. disposable compute.</a:t>
             </a:r>
             <a:endParaRPr lang="en-US" dirty="0"/>
           </a:p>
@@ -896,6 +897,97 @@
             <a:fld id="{F7021451-1387-4CA6-816F-3879F97B5CBC}" type="slidenum">
               <a:rPr lang="en-US"/>
               <a:t>5</a:t>
+            </a:fld>
+            <a:endParaRPr lang="en-US"/>
+          </a:p>
+        </p:txBody>
+      </p:sp>
+    </p:spTree>
+    <p:extLst>
+      <p:ext uri="{BB962C8B-B14F-4D97-AF65-F5344CB8AC3E}">
+        <p14:creationId xmlns:p14="http://schemas.microsoft.com/office/powerpoint/2010/main" val="1024086991"/>
+      </p:ext>
+    </p:extLst>
+  </p:cSld>
+  <p:clrMapOvr>
+    <a:masterClrMapping/>
+  </p:clrMapOvr>
+</p:notes>
+</file>
+
+<file path=ppt/notesSlides/notesSlide6.xml><?xml version="1.0" encoding="utf-8"?>
+<p:notes xmlns:a="http://schemas.openxmlformats.org/drawingml/2006/main" xmlns:r="http://schemas.openxmlformats.org/officeDocument/2006/relationships" xmlns:p="http://schemas.openxmlformats.org/presentationml/2006/main">
+  <p:cSld>
+    <p:spTree>
+      <p:nvGrpSpPr>
+        <p:cNvPr id="1" name=""/>
+        <p:cNvGrpSpPr/>
+        <p:nvPr/>
+      </p:nvGrpSpPr>
+      <p:grpSpPr>
+        <a:xfrm>
+          <a:off x="0" y="0"/>
+          <a:ext cx="0" cy="0"/>
+          <a:chOff x="0" y="0"/>
+          <a:chExt cx="0" cy="0"/>
+        </a:xfrm>
+      </p:grpSpPr>
+      <p:sp>
+        <p:nvSpPr>
+          <p:cNvPr id="2" name="Slide Image Placeholder 1"/>
+          <p:cNvSpPr>
+            <a:spLocks noGrp="1" noRot="1" noChangeAspect="1"/>
+          </p:cNvSpPr>
+          <p:nvPr>
+            <p:ph type="sldImg"/>
+          </p:nvPr>
+        </p:nvSpPr>
+        <p:spPr/>
+      </p:sp>
+      <p:sp>
+        <p:nvSpPr>
+          <p:cNvPr id="3" name="Notes Placeholder 2"/>
+          <p:cNvSpPr>
+            <a:spLocks noGrp="1"/>
+          </p:cNvSpPr>
+          <p:nvPr>
+            <p:ph type="body" idx="1"/>
+          </p:nvPr>
+        </p:nvSpPr>
+        <p:spPr/>
+        <p:txBody>
+          <a:bodyPr/>
+          <a:lstStyle/>
+          <a:p>
+            <a:r>
+              <a:rPr lang="en-US" dirty="0"/>
+              <a:t>DELIVERY: This is a timed pair-share, not a lecture slide. Actually set a 2-minute timer if you have one.
+SAY: Turn to the person next to you. You've each got a task from the start of this section. Two minutes: pick a tool for it, name the first document or dataset you'd load, and say how you'd check the answer before trusting it.
+AFTER 2 MINUTES: Cold-call two or three pairs. Push back gently if someone picks a tool that doesn't fit, e.g., 'that sounds like a live-data question, would grounding in a static doc actually help there?'
+TRANSITION: Close by returning to the two ideas from the previous slide.</a:t>
+            </a:r>
+            <a:endParaRPr lang="en-US" dirty="0"/>
+          </a:p>
+        </p:txBody>
+      </p:sp>
+      <p:sp>
+        <p:nvSpPr>
+          <p:cNvPr id="4" name="Slide Number Placeholder 3"/>
+          <p:cNvSpPr>
+            <a:spLocks noGrp="1"/>
+          </p:cNvSpPr>
+          <p:nvPr>
+            <p:ph type="sldNum" sz="quarter" idx="10"/>
+          </p:nvPr>
+        </p:nvSpPr>
+        <p:spPr/>
+        <p:txBody>
+          <a:bodyPr/>
+          <a:lstStyle/>
+          <a:p>
+            <a:fld id="{F7021451-1387-4CA6-816F-3879F97B5CBC}" type="slidenum">
+              <a:rPr lang="en-US"/>
+              <a:t>6</a:t>
             </a:fld>
             <a:endParaRPr lang="en-US"/>
           </a:p>
@@ -2538,13 +2630,13 @@
             <a:r>
               <a:rPr lang="en-US" sz="1100" b="1" spc="200" kern="0" dirty="0">
                 <a:solidFill>
-                  <a:srgbClr val="059669"/>
-                </a:solidFill>
-                <a:latin typeface="Calibri" pitchFamily="34" charset="0"/>
-                <a:ea typeface="Calibri" pitchFamily="34" charset="-122"/>
-                <a:cs typeface="Calibri" pitchFamily="34" charset="-120"/>
-              </a:rPr>
-              <a:t>GOOGLE COLAB</a:t>
+                  <a:srgbClr val="2563EB"/>
+                </a:solidFill>
+                <a:latin typeface="Calibri" pitchFamily="34" charset="0"/>
+                <a:ea typeface="Calibri" pitchFamily="34" charset="-122"/>
+                <a:cs typeface="Calibri" pitchFamily="34" charset="-120"/>
+              </a:rPr>
+              <a:t>GEMINI NOTEBOOK</a:t>
             </a:r>
             <a:endParaRPr lang="en-US" sz="1100" dirty="0"/>
           </a:p>
@@ -2583,7 +2675,7 @@
                 <a:ea typeface="Calibri" pitchFamily="34" charset="-122"/>
                 <a:cs typeface="Calibri" pitchFamily="34" charset="-120"/>
               </a:rPr>
-              <a:t>Other real-life uses</a:t>
+              <a:t>Beyond chat: the Studio panel</a:t>
             </a:r>
             <a:endParaRPr lang="en-US" sz="2800" dirty="0"/>
           </a:p>
@@ -2597,20 +2689,20 @@
         </p:nvSpPr>
         <p:spPr>
           <a:xfrm>
-            <a:off x="457200" y="1371600"/>
-            <a:ext cx="2624328" cy="1554480"/>
+            <a:off x="457200" y="1261872"/>
+            <a:ext cx="2624328" cy="1207008"/>
           </a:xfrm>
           <a:prstGeom prst="roundRect">
             <a:avLst>
-              <a:gd name="adj" fmla="val 7059"/>
+              <a:gd name="adj" fmla="val 9091"/>
             </a:avLst>
           </a:prstGeom>
           <a:solidFill>
-            <a:srgbClr val="F8FAFC"/>
+            <a:srgbClr val="ECFDF5"/>
           </a:solidFill>
           <a:ln w="12700">
             <a:solidFill>
-              <a:srgbClr val="E2E8F0"/>
+              <a:srgbClr val="A7F3D0"/>
             </a:solidFill>
             <a:prstDash val="solid"/>
           </a:ln>
@@ -2624,8 +2716,8 @@
         </p:nvSpPr>
         <p:spPr>
           <a:xfrm>
-            <a:off x="603504" y="1499616"/>
-            <a:ext cx="384048" cy="384048"/>
+            <a:off x="585216" y="1371600"/>
+            <a:ext cx="329184" cy="329184"/>
           </a:xfrm>
           <a:prstGeom prst="ellipse">
             <a:avLst/>
@@ -2657,8 +2749,8 @@
         </p:blipFill>
         <p:spPr>
           <a:xfrm>
-            <a:off x="703356" y="1599468"/>
-            <a:ext cx="184343" cy="184343"/>
+            <a:off x="670804" y="1457188"/>
+            <a:ext cx="158008" cy="158008"/>
           </a:xfrm>
           <a:prstGeom prst="rect">
             <a:avLst/>
@@ -2673,8 +2765,8 @@
         </p:nvSpPr>
         <p:spPr>
           <a:xfrm>
-            <a:off x="1078992" y="1481328"/>
-            <a:ext cx="1847088" cy="420624"/>
+            <a:off x="987552" y="1353312"/>
+            <a:ext cx="1947672" cy="365760"/>
           </a:xfrm>
           <a:prstGeom prst="rect">
             <a:avLst/>
@@ -2690,7 +2782,7 @@
               <a:buNone/>
             </a:pPr>
             <a:r>
-              <a:rPr lang="en-US" sz="1350" b="1" dirty="0">
+              <a:rPr lang="en-US" sz="1250" b="1" dirty="0">
                 <a:solidFill>
                   <a:srgbClr val="0F172A"/>
                 </a:solidFill>
@@ -2698,9 +2790,9 @@
                 <a:ea typeface="Calibri" pitchFamily="34" charset="-122"/>
                 <a:cs typeface="Calibri" pitchFamily="34" charset="-120"/>
               </a:rPr>
-              <a:t>Data cleaning &amp; EDA</a:t>
-            </a:r>
-            <a:endParaRPr lang="en-US" sz="1350" dirty="0"/>
+              <a:t>Audio Overview</a:t>
+            </a:r>
+            <a:endParaRPr lang="en-US" sz="1250" dirty="0"/>
           </a:p>
         </p:txBody>
       </p:sp>
@@ -2712,8 +2804,47 @@
         </p:nvSpPr>
         <p:spPr>
           <a:xfrm>
-            <a:off x="603504" y="1938528"/>
-            <a:ext cx="2331720" cy="896112"/>
+            <a:off x="585216" y="1700784"/>
+            <a:ext cx="2368296" cy="164592"/>
+          </a:xfrm>
+          <a:prstGeom prst="rect">
+            <a:avLst/>
+          </a:prstGeom>
+          <a:noFill/>
+          <a:ln/>
+        </p:spPr>
+        <p:txBody>
+          <a:bodyPr wrap="square" lIns="0" tIns="0" rIns="0" bIns="0" rtlCol="0" anchor="ctr"/>
+          <a:lstStyle/>
+          <a:p>
+            <a:pPr indent="0" marL="0">
+              <a:buNone/>
+            </a:pPr>
+            <a:r>
+              <a:rPr lang="en-US" sz="750" b="1" spc="100" kern="0" dirty="0">
+                <a:solidFill>
+                  <a:srgbClr val="047857"/>
+                </a:solidFill>
+                <a:latin typeface="Calibri" pitchFamily="34" charset="0"/>
+                <a:ea typeface="Calibri" pitchFamily="34" charset="-122"/>
+                <a:cs typeface="Calibri" pitchFamily="34" charset="-120"/>
+              </a:rPr>
+              <a:t>USED TODAY</a:t>
+            </a:r>
+            <a:endParaRPr lang="en-US" sz="750" dirty="0"/>
+          </a:p>
+        </p:txBody>
+      </p:sp>
+      <p:sp>
+        <p:nvSpPr>
+          <p:cNvPr id="9" name="Text 6"/>
+          <p:cNvSpPr txBox="1"/>
+          <p:nvPr/>
+        </p:nvSpPr>
+        <p:spPr>
+          <a:xfrm>
+            <a:off x="585216" y="1874520"/>
+            <a:ext cx="2368296" cy="493776"/>
           </a:xfrm>
           <a:prstGeom prst="rect">
             <a:avLst/>
@@ -2729,7 +2860,7 @@
               <a:buNone/>
             </a:pPr>
             <a:r>
-              <a:rPr lang="en-US" sz="1050" dirty="0">
+              <a:rPr lang="en-US" sz="950" dirty="0">
                 <a:solidFill>
                   <a:srgbClr val="475569"/>
                 </a:solidFill>
@@ -2737,34 +2868,34 @@
                 <a:ea typeface="Calibri" pitchFamily="34" charset="-122"/>
                 <a:cs typeface="Calibri" pitchFamily="34" charset="-120"/>
               </a:rPr>
-              <a:t>Upload a messy CSV, profile it, clean it and chart it, the same prompt-to-plot pattern from today's demo.</a:t>
-            </a:r>
-            <a:endParaRPr lang="en-US" sz="1050" dirty="0"/>
-          </a:p>
-        </p:txBody>
-      </p:sp>
-      <p:sp>
-        <p:nvSpPr>
-          <p:cNvPr id="9" name="Shape 6"/>
+              <a:t>A podcast-style discussion of your sources.</a:t>
+            </a:r>
+            <a:endParaRPr lang="en-US" sz="950" dirty="0"/>
+          </a:p>
+        </p:txBody>
+      </p:sp>
+      <p:sp>
+        <p:nvSpPr>
+          <p:cNvPr id="10" name="Shape 7"/>
           <p:cNvSpPr/>
           <p:nvPr/>
         </p:nvSpPr>
         <p:spPr>
           <a:xfrm>
-            <a:off x="3200400" y="1371600"/>
-            <a:ext cx="2624328" cy="1554480"/>
+            <a:off x="3200400" y="1261872"/>
+            <a:ext cx="2624328" cy="1207008"/>
           </a:xfrm>
           <a:prstGeom prst="roundRect">
             <a:avLst>
-              <a:gd name="adj" fmla="val 7059"/>
+              <a:gd name="adj" fmla="val 9091"/>
             </a:avLst>
           </a:prstGeom>
           <a:solidFill>
-            <a:srgbClr val="F8FAFC"/>
+            <a:srgbClr val="ECFDF5"/>
           </a:solidFill>
           <a:ln w="12700">
             <a:solidFill>
-              <a:srgbClr val="E2E8F0"/>
+              <a:srgbClr val="A7F3D0"/>
             </a:solidFill>
             <a:prstDash val="solid"/>
           </a:ln>
@@ -2772,14 +2903,14 @@
       </p:sp>
       <p:sp>
         <p:nvSpPr>
-          <p:cNvPr id="10" name="Shape 7"/>
+          <p:cNvPr id="11" name="Shape 8"/>
           <p:cNvSpPr/>
           <p:nvPr/>
         </p:nvSpPr>
         <p:spPr>
           <a:xfrm>
-            <a:off x="3346704" y="1499616"/>
-            <a:ext cx="384048" cy="384048"/>
+            <a:off x="3328416" y="1371600"/>
+            <a:ext cx="329184" cy="329184"/>
           </a:xfrm>
           <a:prstGeom prst="ellipse">
             <a:avLst/>
@@ -2797,7 +2928,7 @@
       </p:sp>
       <p:pic>
         <p:nvPicPr>
-          <p:cNvPr id="11" name="Image 1" descr="preencoded.png">    </p:cNvPr>
+          <p:cNvPr id="12" name="Image 1" descr="preencoded.png">    </p:cNvPr>
           <p:cNvPicPr>
             <a:picLocks noChangeAspect="1"/>
           </p:cNvPicPr>
@@ -2811,8 +2942,8 @@
         </p:blipFill>
         <p:spPr>
           <a:xfrm>
-            <a:off x="3446556" y="1599468"/>
-            <a:ext cx="184343" cy="184343"/>
+            <a:off x="3414004" y="1457188"/>
+            <a:ext cx="158008" cy="158008"/>
           </a:xfrm>
           <a:prstGeom prst="rect">
             <a:avLst/>
@@ -2821,14 +2952,14 @@
       </p:pic>
       <p:sp>
         <p:nvSpPr>
-          <p:cNvPr id="12" name="Text 8"/>
-          <p:cNvSpPr txBox="1"/>
-          <p:nvPr/>
-        </p:nvSpPr>
-        <p:spPr>
-          <a:xfrm>
-            <a:off x="3822192" y="1481328"/>
-            <a:ext cx="1847088" cy="420624"/>
+          <p:cNvPr id="13" name="Text 9"/>
+          <p:cNvSpPr txBox="1"/>
+          <p:nvPr/>
+        </p:nvSpPr>
+        <p:spPr>
+          <a:xfrm>
+            <a:off x="3730752" y="1353312"/>
+            <a:ext cx="1947672" cy="365760"/>
           </a:xfrm>
           <a:prstGeom prst="rect">
             <a:avLst/>
@@ -2844,7 +2975,7 @@
               <a:buNone/>
             </a:pPr>
             <a:r>
-              <a:rPr lang="en-US" sz="1350" b="1" dirty="0">
+              <a:rPr lang="en-US" sz="1250" b="1" dirty="0">
                 <a:solidFill>
                   <a:srgbClr val="0F172A"/>
                 </a:solidFill>
@@ -2852,22 +2983,61 @@
                 <a:ea typeface="Calibri" pitchFamily="34" charset="-122"/>
                 <a:cs typeface="Calibri" pitchFamily="34" charset="-120"/>
               </a:rPr>
-              <a:t>Model prototyping</a:t>
-            </a:r>
-            <a:endParaRPr lang="en-US" sz="1350" dirty="0"/>
-          </a:p>
-        </p:txBody>
-      </p:sp>
-      <p:sp>
-        <p:nvSpPr>
-          <p:cNvPr id="13" name="Text 9"/>
-          <p:cNvSpPr txBox="1"/>
-          <p:nvPr/>
-        </p:nvSpPr>
-        <p:spPr>
-          <a:xfrm>
-            <a:off x="3346704" y="1938528"/>
-            <a:ext cx="2331720" cy="896112"/>
+              <a:t>Quiz</a:t>
+            </a:r>
+            <a:endParaRPr lang="en-US" sz="1250" dirty="0"/>
+          </a:p>
+        </p:txBody>
+      </p:sp>
+      <p:sp>
+        <p:nvSpPr>
+          <p:cNvPr id="14" name="Text 10"/>
+          <p:cNvSpPr txBox="1"/>
+          <p:nvPr/>
+        </p:nvSpPr>
+        <p:spPr>
+          <a:xfrm>
+            <a:off x="3328416" y="1700784"/>
+            <a:ext cx="2368296" cy="164592"/>
+          </a:xfrm>
+          <a:prstGeom prst="rect">
+            <a:avLst/>
+          </a:prstGeom>
+          <a:noFill/>
+          <a:ln/>
+        </p:spPr>
+        <p:txBody>
+          <a:bodyPr wrap="square" lIns="0" tIns="0" rIns="0" bIns="0" rtlCol="0" anchor="ctr"/>
+          <a:lstStyle/>
+          <a:p>
+            <a:pPr indent="0" marL="0">
+              <a:buNone/>
+            </a:pPr>
+            <a:r>
+              <a:rPr lang="en-US" sz="750" b="1" spc="100" kern="0" dirty="0">
+                <a:solidFill>
+                  <a:srgbClr val="047857"/>
+                </a:solidFill>
+                <a:latin typeface="Calibri" pitchFamily="34" charset="0"/>
+                <a:ea typeface="Calibri" pitchFamily="34" charset="-122"/>
+                <a:cs typeface="Calibri" pitchFamily="34" charset="-120"/>
+              </a:rPr>
+              <a:t>USED TODAY</a:t>
+            </a:r>
+            <a:endParaRPr lang="en-US" sz="750" dirty="0"/>
+          </a:p>
+        </p:txBody>
+      </p:sp>
+      <p:sp>
+        <p:nvSpPr>
+          <p:cNvPr id="15" name="Text 11"/>
+          <p:cNvSpPr txBox="1"/>
+          <p:nvPr/>
+        </p:nvSpPr>
+        <p:spPr>
+          <a:xfrm>
+            <a:off x="3328416" y="1874520"/>
+            <a:ext cx="2368296" cy="493776"/>
           </a:xfrm>
           <a:prstGeom prst="rect">
             <a:avLst/>
@@ -2883,7 +3053,7 @@
               <a:buNone/>
             </a:pPr>
             <a:r>
-              <a:rPr lang="en-US" sz="1050" dirty="0">
+              <a:rPr lang="en-US" sz="950" dirty="0">
                 <a:solidFill>
                   <a:srgbClr val="475569"/>
                 </a:solidFill>
@@ -2891,26 +3061,26 @@
                 <a:ea typeface="Calibri" pitchFamily="34" charset="-122"/>
                 <a:cs typeface="Calibri" pitchFamily="34" charset="-120"/>
               </a:rPr>
-              <a:t>Try a small model or a fine-tune on a free GPU before deciding it's worth dedicated infrastructure.</a:t>
-            </a:r>
-            <a:endParaRPr lang="en-US" sz="1050" dirty="0"/>
-          </a:p>
-        </p:txBody>
-      </p:sp>
-      <p:sp>
-        <p:nvSpPr>
-          <p:cNvPr id="14" name="Shape 10"/>
+              <a:t>Interactive questions with explanations, cited back to your sources.</a:t>
+            </a:r>
+            <a:endParaRPr lang="en-US" sz="950" dirty="0"/>
+          </a:p>
+        </p:txBody>
+      </p:sp>
+      <p:sp>
+        <p:nvSpPr>
+          <p:cNvPr id="16" name="Shape 12"/>
           <p:cNvSpPr/>
           <p:nvPr/>
         </p:nvSpPr>
         <p:spPr>
           <a:xfrm>
-            <a:off x="5943600" y="1371600"/>
-            <a:ext cx="2624328" cy="1554480"/>
+            <a:off x="5943600" y="1261872"/>
+            <a:ext cx="2624328" cy="1207008"/>
           </a:xfrm>
           <a:prstGeom prst="roundRect">
             <a:avLst>
-              <a:gd name="adj" fmla="val 7059"/>
+              <a:gd name="adj" fmla="val 9091"/>
             </a:avLst>
           </a:prstGeom>
           <a:solidFill>
@@ -2926,24 +3096,24 @@
       </p:sp>
       <p:sp>
         <p:nvSpPr>
-          <p:cNvPr id="15" name="Shape 11"/>
+          <p:cNvPr id="17" name="Shape 13"/>
           <p:cNvSpPr/>
           <p:nvPr/>
         </p:nvSpPr>
         <p:spPr>
           <a:xfrm>
-            <a:off x="6089904" y="1499616"/>
-            <a:ext cx="384048" cy="384048"/>
+            <a:off x="6071616" y="1371600"/>
+            <a:ext cx="329184" cy="329184"/>
           </a:xfrm>
           <a:prstGeom prst="ellipse">
             <a:avLst/>
           </a:prstGeom>
           <a:solidFill>
-            <a:srgbClr val="D1FAE5"/>
+            <a:srgbClr val="F1F5F9"/>
           </a:solidFill>
           <a:ln w="12700">
             <a:solidFill>
-              <a:srgbClr val="D1FAE5"/>
+              <a:srgbClr val="F1F5F9"/>
             </a:solidFill>
             <a:prstDash val="solid"/>
           </a:ln>
@@ -2951,7 +3121,7 @@
       </p:sp>
       <p:pic>
         <p:nvPicPr>
-          <p:cNvPr id="16" name="Image 2" descr="preencoded.png">    </p:cNvPr>
+          <p:cNvPr id="18" name="Image 2" descr="preencoded.png">    </p:cNvPr>
           <p:cNvPicPr>
             <a:picLocks noChangeAspect="1"/>
           </p:cNvPicPr>
@@ -2965,8 +3135,8 @@
         </p:blipFill>
         <p:spPr>
           <a:xfrm>
-            <a:off x="6189756" y="1599468"/>
-            <a:ext cx="184343" cy="184343"/>
+            <a:off x="6157204" y="1457188"/>
+            <a:ext cx="158008" cy="158008"/>
           </a:xfrm>
           <a:prstGeom prst="rect">
             <a:avLst/>
@@ -2975,14 +3145,14 @@
       </p:pic>
       <p:sp>
         <p:nvSpPr>
-          <p:cNvPr id="17" name="Text 12"/>
-          <p:cNvSpPr txBox="1"/>
-          <p:nvPr/>
-        </p:nvSpPr>
-        <p:spPr>
-          <a:xfrm>
-            <a:off x="6565392" y="1481328"/>
-            <a:ext cx="1847088" cy="420624"/>
+          <p:cNvPr id="19" name="Text 14"/>
+          <p:cNvSpPr txBox="1"/>
+          <p:nvPr/>
+        </p:nvSpPr>
+        <p:spPr>
+          <a:xfrm>
+            <a:off x="6473952" y="1353312"/>
+            <a:ext cx="1947672" cy="365760"/>
           </a:xfrm>
           <a:prstGeom prst="rect">
             <a:avLst/>
@@ -2998,7 +3168,7 @@
               <a:buNone/>
             </a:pPr>
             <a:r>
-              <a:rPr lang="en-US" sz="1350" b="1" dirty="0">
+              <a:rPr lang="en-US" sz="1250" b="1" dirty="0">
                 <a:solidFill>
                   <a:srgbClr val="0F172A"/>
                 </a:solidFill>
@@ -3006,22 +3176,22 @@
                 <a:ea typeface="Calibri" pitchFamily="34" charset="-122"/>
                 <a:cs typeface="Calibri" pitchFamily="34" charset="-120"/>
               </a:rPr>
-              <a:t>Teaching &amp; shared homework</a:t>
-            </a:r>
-            <a:endParaRPr lang="en-US" sz="1350" dirty="0"/>
-          </a:p>
-        </p:txBody>
-      </p:sp>
-      <p:sp>
-        <p:nvSpPr>
-          <p:cNvPr id="18" name="Text 13"/>
-          <p:cNvSpPr txBox="1"/>
-          <p:nvPr/>
-        </p:nvSpPr>
-        <p:spPr>
-          <a:xfrm>
-            <a:off x="6089904" y="1938528"/>
-            <a:ext cx="2331720" cy="896112"/>
+              <a:t>Data Table</a:t>
+            </a:r>
+            <a:endParaRPr lang="en-US" sz="1250" dirty="0"/>
+          </a:p>
+        </p:txBody>
+      </p:sp>
+      <p:sp>
+        <p:nvSpPr>
+          <p:cNvPr id="20" name="Text 15"/>
+          <p:cNvSpPr txBox="1"/>
+          <p:nvPr/>
+        </p:nvSpPr>
+        <p:spPr>
+          <a:xfrm>
+            <a:off x="6071616" y="1719072"/>
+            <a:ext cx="2368296" cy="658368"/>
           </a:xfrm>
           <a:prstGeom prst="rect">
             <a:avLst/>
@@ -3037,7 +3207,7 @@
               <a:buNone/>
             </a:pPr>
             <a:r>
-              <a:rPr lang="en-US" sz="1050" dirty="0">
+              <a:rPr lang="en-US" sz="950" dirty="0">
                 <a:solidFill>
                   <a:srgbClr val="475569"/>
                 </a:solidFill>
@@ -3045,26 +3215,26 @@
                 <a:ea typeface="Calibri" pitchFamily="34" charset="-122"/>
                 <a:cs typeface="Calibri" pitchFamily="34" charset="-120"/>
               </a:rPr>
-              <a:t>Share one notebook link so every student runs identical code with zero setup.</a:t>
-            </a:r>
-            <a:endParaRPr lang="en-US" sz="1050" dirty="0"/>
-          </a:p>
-        </p:txBody>
-      </p:sp>
-      <p:sp>
-        <p:nvSpPr>
-          <p:cNvPr id="19" name="Shape 14"/>
+              <a:t>Pulls structured rows and columns out of your sources, with citations.</a:t>
+            </a:r>
+            <a:endParaRPr lang="en-US" sz="950" dirty="0"/>
+          </a:p>
+        </p:txBody>
+      </p:sp>
+      <p:sp>
+        <p:nvSpPr>
+          <p:cNvPr id="21" name="Shape 16"/>
           <p:cNvSpPr/>
           <p:nvPr/>
         </p:nvSpPr>
         <p:spPr>
           <a:xfrm>
-            <a:off x="457200" y="3063240"/>
-            <a:ext cx="2624328" cy="1554480"/>
+            <a:off x="457200" y="2569464"/>
+            <a:ext cx="2624328" cy="1207008"/>
           </a:xfrm>
           <a:prstGeom prst="roundRect">
             <a:avLst>
-              <a:gd name="adj" fmla="val 7059"/>
+              <a:gd name="adj" fmla="val 9091"/>
             </a:avLst>
           </a:prstGeom>
           <a:solidFill>
@@ -3080,24 +3250,24 @@
       </p:sp>
       <p:sp>
         <p:nvSpPr>
-          <p:cNvPr id="20" name="Shape 15"/>
+          <p:cNvPr id="22" name="Shape 17"/>
           <p:cNvSpPr/>
           <p:nvPr/>
         </p:nvSpPr>
         <p:spPr>
           <a:xfrm>
-            <a:off x="603504" y="3191256"/>
-            <a:ext cx="384048" cy="384048"/>
+            <a:off x="585216" y="2679192"/>
+            <a:ext cx="329184" cy="329184"/>
           </a:xfrm>
           <a:prstGeom prst="ellipse">
             <a:avLst/>
           </a:prstGeom>
           <a:solidFill>
-            <a:srgbClr val="D1FAE5"/>
+            <a:srgbClr val="F1F5F9"/>
           </a:solidFill>
           <a:ln w="12700">
             <a:solidFill>
-              <a:srgbClr val="D1FAE5"/>
+              <a:srgbClr val="F1F5F9"/>
             </a:solidFill>
             <a:prstDash val="solid"/>
           </a:ln>
@@ -3105,7 +3275,7 @@
       </p:sp>
       <p:pic>
         <p:nvPicPr>
-          <p:cNvPr id="21" name="Image 3" descr="preencoded.png">    </p:cNvPr>
+          <p:cNvPr id="23" name="Image 3" descr="preencoded.png">    </p:cNvPr>
           <p:cNvPicPr>
             <a:picLocks noChangeAspect="1"/>
           </p:cNvPicPr>
@@ -3119,8 +3289,8 @@
         </p:blipFill>
         <p:spPr>
           <a:xfrm>
-            <a:off x="703356" y="3291108"/>
-            <a:ext cx="184343" cy="184343"/>
+            <a:off x="670804" y="2764780"/>
+            <a:ext cx="158008" cy="158008"/>
           </a:xfrm>
           <a:prstGeom prst="rect">
             <a:avLst/>
@@ -3129,14 +3299,14 @@
       </p:pic>
       <p:sp>
         <p:nvSpPr>
-          <p:cNvPr id="22" name="Text 16"/>
-          <p:cNvSpPr txBox="1"/>
-          <p:nvPr/>
-        </p:nvSpPr>
-        <p:spPr>
-          <a:xfrm>
-            <a:off x="1078992" y="3172968"/>
-            <a:ext cx="1847088" cy="420624"/>
+          <p:cNvPr id="24" name="Text 18"/>
+          <p:cNvSpPr txBox="1"/>
+          <p:nvPr/>
+        </p:nvSpPr>
+        <p:spPr>
+          <a:xfrm>
+            <a:off x="987552" y="2660904"/>
+            <a:ext cx="1947672" cy="365760"/>
           </a:xfrm>
           <a:prstGeom prst="rect">
             <a:avLst/>
@@ -3152,7 +3322,7 @@
               <a:buNone/>
             </a:pPr>
             <a:r>
-              <a:rPr lang="en-US" sz="1350" b="1" dirty="0">
+              <a:rPr lang="en-US" sz="1250" b="1" dirty="0">
                 <a:solidFill>
                   <a:srgbClr val="0F172A"/>
                 </a:solidFill>
@@ -3160,22 +3330,22 @@
                 <a:ea typeface="Calibri" pitchFamily="34" charset="-122"/>
                 <a:cs typeface="Calibri" pitchFamily="34" charset="-120"/>
               </a:rPr>
-              <a:t>One-off automation</a:t>
-            </a:r>
-            <a:endParaRPr lang="en-US" sz="1350" dirty="0"/>
-          </a:p>
-        </p:txBody>
-      </p:sp>
-      <p:sp>
-        <p:nvSpPr>
-          <p:cNvPr id="23" name="Text 17"/>
-          <p:cNvSpPr txBox="1"/>
-          <p:nvPr/>
-        </p:nvSpPr>
-        <p:spPr>
-          <a:xfrm>
-            <a:off x="603504" y="3630168"/>
-            <a:ext cx="2331720" cy="896112"/>
+              <a:t>Mind Map</a:t>
+            </a:r>
+            <a:endParaRPr lang="en-US" sz="1250" dirty="0"/>
+          </a:p>
+        </p:txBody>
+      </p:sp>
+      <p:sp>
+        <p:nvSpPr>
+          <p:cNvPr id="25" name="Text 19"/>
+          <p:cNvSpPr txBox="1"/>
+          <p:nvPr/>
+        </p:nvSpPr>
+        <p:spPr>
+          <a:xfrm>
+            <a:off x="585216" y="3026664"/>
+            <a:ext cx="2368296" cy="658368"/>
           </a:xfrm>
           <a:prstGeom prst="rect">
             <a:avLst/>
@@ -3191,7 +3361,7 @@
               <a:buNone/>
             </a:pPr>
             <a:r>
-              <a:rPr lang="en-US" sz="1050" dirty="0">
+              <a:rPr lang="en-US" sz="950" dirty="0">
                 <a:solidFill>
                   <a:srgbClr val="475569"/>
                 </a:solidFill>
@@ -3199,26 +3369,26 @@
                 <a:ea typeface="Calibri" pitchFamily="34" charset="-122"/>
                 <a:cs typeface="Calibri" pitchFamily="34" charset="-120"/>
               </a:rPr>
-              <a:t>A scrape-and-report script that runs occasionally and doesn't justify its own server.</a:t>
-            </a:r>
-            <a:endParaRPr lang="en-US" sz="1050" dirty="0"/>
-          </a:p>
-        </p:txBody>
-      </p:sp>
-      <p:sp>
-        <p:nvSpPr>
-          <p:cNvPr id="24" name="Shape 18"/>
+              <a:t>An interactive diagram of how the ideas in your sources connect.</a:t>
+            </a:r>
+            <a:endParaRPr lang="en-US" sz="950" dirty="0"/>
+          </a:p>
+        </p:txBody>
+      </p:sp>
+      <p:sp>
+        <p:nvSpPr>
+          <p:cNvPr id="26" name="Shape 20"/>
           <p:cNvSpPr/>
           <p:nvPr/>
         </p:nvSpPr>
         <p:spPr>
           <a:xfrm>
-            <a:off x="3200400" y="3063240"/>
-            <a:ext cx="2624328" cy="1554480"/>
+            <a:off x="3200400" y="2569464"/>
+            <a:ext cx="2624328" cy="1207008"/>
           </a:xfrm>
           <a:prstGeom prst="roundRect">
             <a:avLst>
-              <a:gd name="adj" fmla="val 7059"/>
+              <a:gd name="adj" fmla="val 9091"/>
             </a:avLst>
           </a:prstGeom>
           <a:solidFill>
@@ -3234,24 +3404,24 @@
       </p:sp>
       <p:sp>
         <p:nvSpPr>
-          <p:cNvPr id="25" name="Shape 19"/>
+          <p:cNvPr id="27" name="Shape 21"/>
           <p:cNvSpPr/>
           <p:nvPr/>
         </p:nvSpPr>
         <p:spPr>
           <a:xfrm>
-            <a:off x="3346704" y="3191256"/>
-            <a:ext cx="384048" cy="384048"/>
+            <a:off x="3328416" y="2679192"/>
+            <a:ext cx="329184" cy="329184"/>
           </a:xfrm>
           <a:prstGeom prst="ellipse">
             <a:avLst/>
           </a:prstGeom>
           <a:solidFill>
-            <a:srgbClr val="D1FAE5"/>
+            <a:srgbClr val="F1F5F9"/>
           </a:solidFill>
           <a:ln w="12700">
             <a:solidFill>
-              <a:srgbClr val="D1FAE5"/>
+              <a:srgbClr val="F1F5F9"/>
             </a:solidFill>
             <a:prstDash val="solid"/>
           </a:ln>
@@ -3259,7 +3429,7 @@
       </p:sp>
       <p:pic>
         <p:nvPicPr>
-          <p:cNvPr id="26" name="Image 4" descr="preencoded.png">    </p:cNvPr>
+          <p:cNvPr id="28" name="Image 4" descr="preencoded.png">    </p:cNvPr>
           <p:cNvPicPr>
             <a:picLocks noChangeAspect="1"/>
           </p:cNvPicPr>
@@ -3273,8 +3443,8 @@
         </p:blipFill>
         <p:spPr>
           <a:xfrm>
-            <a:off x="3446556" y="3291108"/>
-            <a:ext cx="184343" cy="184343"/>
+            <a:off x="3414004" y="2764780"/>
+            <a:ext cx="158008" cy="158008"/>
           </a:xfrm>
           <a:prstGeom prst="rect">
             <a:avLst/>
@@ -3283,14 +3453,14 @@
       </p:pic>
       <p:sp>
         <p:nvSpPr>
-          <p:cNvPr id="27" name="Text 20"/>
-          <p:cNvSpPr txBox="1"/>
-          <p:nvPr/>
-        </p:nvSpPr>
-        <p:spPr>
-          <a:xfrm>
-            <a:off x="3822192" y="3172968"/>
-            <a:ext cx="1847088" cy="420624"/>
+          <p:cNvPr id="29" name="Text 22"/>
+          <p:cNvSpPr txBox="1"/>
+          <p:nvPr/>
+        </p:nvSpPr>
+        <p:spPr>
+          <a:xfrm>
+            <a:off x="3730752" y="2660904"/>
+            <a:ext cx="1947672" cy="365760"/>
           </a:xfrm>
           <a:prstGeom prst="rect">
             <a:avLst/>
@@ -3306,7 +3476,7 @@
               <a:buNone/>
             </a:pPr>
             <a:r>
-              <a:rPr lang="en-US" sz="1350" b="1" dirty="0">
+              <a:rPr lang="en-US" sz="1250" b="1" dirty="0">
                 <a:solidFill>
                   <a:srgbClr val="0F172A"/>
                 </a:solidFill>
@@ -3314,22 +3484,22 @@
                 <a:ea typeface="Calibri" pitchFamily="34" charset="-122"/>
                 <a:cs typeface="Calibri" pitchFamily="34" charset="-120"/>
               </a:rPr>
-              <a:t>Collaborative debugging</a:t>
-            </a:r>
-            <a:endParaRPr lang="en-US" sz="1350" dirty="0"/>
-          </a:p>
-        </p:txBody>
-      </p:sp>
-      <p:sp>
-        <p:nvSpPr>
-          <p:cNvPr id="28" name="Text 21"/>
-          <p:cNvSpPr txBox="1"/>
-          <p:nvPr/>
-        </p:nvSpPr>
-        <p:spPr>
-          <a:xfrm>
-            <a:off x="3346704" y="3630168"/>
-            <a:ext cx="2331720" cy="896112"/>
+              <a:t>Reports</a:t>
+            </a:r>
+            <a:endParaRPr lang="en-US" sz="1250" dirty="0"/>
+          </a:p>
+        </p:txBody>
+      </p:sp>
+      <p:sp>
+        <p:nvSpPr>
+          <p:cNvPr id="30" name="Text 23"/>
+          <p:cNvSpPr txBox="1"/>
+          <p:nvPr/>
+        </p:nvSpPr>
+        <p:spPr>
+          <a:xfrm>
+            <a:off x="3328416" y="3026664"/>
+            <a:ext cx="2368296" cy="658368"/>
           </a:xfrm>
           <a:prstGeom prst="rect">
             <a:avLst/>
@@ -3345,7 +3515,7 @@
               <a:buNone/>
             </a:pPr>
             <a:r>
-              <a:rPr lang="en-US" sz="1050" dirty="0">
+              <a:rPr lang="en-US" sz="950" dirty="0">
                 <a:solidFill>
                   <a:srgbClr val="475569"/>
                 </a:solidFill>
@@ -3353,34 +3523,34 @@
                 <a:ea typeface="Calibri" pitchFamily="34" charset="-122"/>
                 <a:cs typeface="Calibri" pitchFamily="34" charset="-120"/>
               </a:rPr>
-              <a:t>Two people open the same notebook; one triggers an error, the other reviews the suggested fix.</a:t>
-            </a:r>
-            <a:endParaRPr lang="en-US" sz="1050" dirty="0"/>
-          </a:p>
-        </p:txBody>
-      </p:sp>
-      <p:sp>
-        <p:nvSpPr>
-          <p:cNvPr id="29" name="Shape 22"/>
+              <a:t>A briefing doc, FAQ, or study guide built from your sources.</a:t>
+            </a:r>
+            <a:endParaRPr lang="en-US" sz="950" dirty="0"/>
+          </a:p>
+        </p:txBody>
+      </p:sp>
+      <p:sp>
+        <p:nvSpPr>
+          <p:cNvPr id="31" name="Shape 24"/>
           <p:cNvSpPr/>
           <p:nvPr/>
         </p:nvSpPr>
         <p:spPr>
           <a:xfrm>
-            <a:off x="5943600" y="3063240"/>
-            <a:ext cx="2624328" cy="1554480"/>
+            <a:off x="5943600" y="2569464"/>
+            <a:ext cx="2624328" cy="1207008"/>
           </a:xfrm>
           <a:prstGeom prst="roundRect">
             <a:avLst>
-              <a:gd name="adj" fmla="val 7059"/>
+              <a:gd name="adj" fmla="val 9091"/>
             </a:avLst>
           </a:prstGeom>
           <a:solidFill>
-            <a:srgbClr val="FFFBEB"/>
+            <a:srgbClr val="F8FAFC"/>
           </a:solidFill>
           <a:ln w="12700">
             <a:solidFill>
-              <a:srgbClr val="FDE68A"/>
+              <a:srgbClr val="E2E8F0"/>
             </a:solidFill>
             <a:prstDash val="solid"/>
           </a:ln>
@@ -3388,24 +3558,24 @@
       </p:sp>
       <p:sp>
         <p:nvSpPr>
-          <p:cNvPr id="30" name="Shape 23"/>
+          <p:cNvPr id="32" name="Shape 25"/>
           <p:cNvSpPr/>
           <p:nvPr/>
         </p:nvSpPr>
         <p:spPr>
           <a:xfrm>
-            <a:off x="6089904" y="3191256"/>
-            <a:ext cx="384048" cy="384048"/>
+            <a:off x="6071616" y="2679192"/>
+            <a:ext cx="329184" cy="329184"/>
           </a:xfrm>
           <a:prstGeom prst="ellipse">
             <a:avLst/>
           </a:prstGeom>
           <a:solidFill>
-            <a:srgbClr val="FEF3C7"/>
+            <a:srgbClr val="F1F5F9"/>
           </a:solidFill>
           <a:ln w="12700">
             <a:solidFill>
-              <a:srgbClr val="FEF3C7"/>
+              <a:srgbClr val="F1F5F9"/>
             </a:solidFill>
             <a:prstDash val="solid"/>
           </a:ln>
@@ -3413,7 +3583,7 @@
       </p:sp>
       <p:pic>
         <p:nvPicPr>
-          <p:cNvPr id="31" name="Image 5" descr="preencoded.png">    </p:cNvPr>
+          <p:cNvPr id="33" name="Image 5" descr="preencoded.png">    </p:cNvPr>
           <p:cNvPicPr>
             <a:picLocks noChangeAspect="1"/>
           </p:cNvPicPr>
@@ -3427,8 +3597,8 @@
         </p:blipFill>
         <p:spPr>
           <a:xfrm>
-            <a:off x="6189756" y="3291108"/>
-            <a:ext cx="184343" cy="184343"/>
+            <a:off x="6157204" y="2764780"/>
+            <a:ext cx="158008" cy="158008"/>
           </a:xfrm>
           <a:prstGeom prst="rect">
             <a:avLst/>
@@ -3437,14 +3607,14 @@
       </p:pic>
       <p:sp>
         <p:nvSpPr>
-          <p:cNvPr id="32" name="Text 24"/>
-          <p:cNvSpPr txBox="1"/>
-          <p:nvPr/>
-        </p:nvSpPr>
-        <p:spPr>
-          <a:xfrm>
-            <a:off x="6565392" y="3172968"/>
-            <a:ext cx="1847088" cy="420624"/>
+          <p:cNvPr id="34" name="Text 26"/>
+          <p:cNvSpPr txBox="1"/>
+          <p:nvPr/>
+        </p:nvSpPr>
+        <p:spPr>
+          <a:xfrm>
+            <a:off x="6473952" y="2660904"/>
+            <a:ext cx="1947672" cy="365760"/>
           </a:xfrm>
           <a:prstGeom prst="rect">
             <a:avLst/>
@@ -3460,30 +3630,30 @@
               <a:buNone/>
             </a:pPr>
             <a:r>
-              <a:rPr lang="en-US" sz="1350" b="1" dirty="0">
-                <a:solidFill>
-                  <a:srgbClr val="78350F"/>
-                </a:solidFill>
-                <a:latin typeface="Calibri" pitchFamily="34" charset="0"/>
-                <a:ea typeface="Calibri" pitchFamily="34" charset="-122"/>
-                <a:cs typeface="Calibri" pitchFamily="34" charset="-120"/>
-              </a:rPr>
-              <a:t>Your turn</a:t>
-            </a:r>
-            <a:endParaRPr lang="en-US" sz="1350" dirty="0"/>
-          </a:p>
-        </p:txBody>
-      </p:sp>
-      <p:sp>
-        <p:nvSpPr>
-          <p:cNvPr id="33" name="Text 25"/>
-          <p:cNvSpPr txBox="1"/>
-          <p:nvPr/>
-        </p:nvSpPr>
-        <p:spPr>
-          <a:xfrm>
-            <a:off x="6089904" y="3630168"/>
-            <a:ext cx="2331720" cy="896112"/>
+              <a:rPr lang="en-US" sz="1250" b="1" dirty="0">
+                <a:solidFill>
+                  <a:srgbClr val="0F172A"/>
+                </a:solidFill>
+                <a:latin typeface="Calibri" pitchFamily="34" charset="0"/>
+                <a:ea typeface="Calibri" pitchFamily="34" charset="-122"/>
+                <a:cs typeface="Calibri" pitchFamily="34" charset="-120"/>
+              </a:rPr>
+              <a:t>Infographic</a:t>
+            </a:r>
+            <a:endParaRPr lang="en-US" sz="1250" dirty="0"/>
+          </a:p>
+        </p:txBody>
+      </p:sp>
+      <p:sp>
+        <p:nvSpPr>
+          <p:cNvPr id="35" name="Text 27"/>
+          <p:cNvSpPr txBox="1"/>
+          <p:nvPr/>
+        </p:nvSpPr>
+        <p:spPr>
+          <a:xfrm>
+            <a:off x="6071616" y="3026664"/>
+            <a:ext cx="2368296" cy="658368"/>
           </a:xfrm>
           <a:prstGeom prst="rect">
             <a:avLst/>
@@ -3499,17 +3669,479 @@
               <a:buNone/>
             </a:pPr>
             <a:r>
-              <a:rPr lang="en-US" sz="1050" i="1" dirty="0">
-                <a:solidFill>
-                  <a:srgbClr val="78350F"/>
-                </a:solidFill>
-                <a:latin typeface="Calibri" pitchFamily="34" charset="0"/>
-                <a:ea typeface="Calibri" pitchFamily="34" charset="-122"/>
-                <a:cs typeface="Calibri" pitchFamily="34" charset="-120"/>
-              </a:rPr>
-              <a:t>What's a script or analysis you avoid because setting it up feels like too much work?</a:t>
-            </a:r>
-            <a:endParaRPr lang="en-US" sz="1050" dirty="0"/>
+              <a:rPr lang="en-US" sz="950" dirty="0">
+                <a:solidFill>
+                  <a:srgbClr val="475569"/>
+                </a:solidFill>
+                <a:latin typeface="Calibri" pitchFamily="34" charset="0"/>
+                <a:ea typeface="Calibri" pitchFamily="34" charset="-122"/>
+                <a:cs typeface="Calibri" pitchFamily="34" charset="-120"/>
+              </a:rPr>
+              <a:t>A single visual summary of your sources.</a:t>
+            </a:r>
+            <a:endParaRPr lang="en-US" sz="950" dirty="0"/>
+          </a:p>
+        </p:txBody>
+      </p:sp>
+      <p:sp>
+        <p:nvSpPr>
+          <p:cNvPr id="36" name="Shape 28"/>
+          <p:cNvSpPr/>
+          <p:nvPr/>
+        </p:nvSpPr>
+        <p:spPr>
+          <a:xfrm>
+            <a:off x="457200" y="3877056"/>
+            <a:ext cx="2624328" cy="1207008"/>
+          </a:xfrm>
+          <a:prstGeom prst="roundRect">
+            <a:avLst>
+              <a:gd name="adj" fmla="val 9091"/>
+            </a:avLst>
+          </a:prstGeom>
+          <a:solidFill>
+            <a:srgbClr val="F8FAFC"/>
+          </a:solidFill>
+          <a:ln w="12700">
+            <a:solidFill>
+              <a:srgbClr val="E2E8F0"/>
+            </a:solidFill>
+            <a:prstDash val="solid"/>
+          </a:ln>
+        </p:spPr>
+      </p:sp>
+      <p:sp>
+        <p:nvSpPr>
+          <p:cNvPr id="37" name="Shape 29"/>
+          <p:cNvSpPr/>
+          <p:nvPr/>
+        </p:nvSpPr>
+        <p:spPr>
+          <a:xfrm>
+            <a:off x="585216" y="3986784"/>
+            <a:ext cx="329184" cy="329184"/>
+          </a:xfrm>
+          <a:prstGeom prst="ellipse">
+            <a:avLst/>
+          </a:prstGeom>
+          <a:solidFill>
+            <a:srgbClr val="F1F5F9"/>
+          </a:solidFill>
+          <a:ln w="12700">
+            <a:solidFill>
+              <a:srgbClr val="F1F5F9"/>
+            </a:solidFill>
+            <a:prstDash val="solid"/>
+          </a:ln>
+        </p:spPr>
+      </p:sp>
+      <p:pic>
+        <p:nvPicPr>
+          <p:cNvPr id="38" name="Image 6" descr="preencoded.png">    </p:cNvPr>
+          <p:cNvPicPr>
+            <a:picLocks noChangeAspect="1"/>
+          </p:cNvPicPr>
+          <p:nvPr/>
+        </p:nvPicPr>
+        <p:blipFill>
+          <a:blip r:embed="rId7"/>
+          <a:stretch>
+            <a:fillRect/>
+          </a:stretch>
+        </p:blipFill>
+        <p:spPr>
+          <a:xfrm>
+            <a:off x="670804" y="4072372"/>
+            <a:ext cx="158008" cy="158008"/>
+          </a:xfrm>
+          <a:prstGeom prst="rect">
+            <a:avLst/>
+          </a:prstGeom>
+        </p:spPr>
+      </p:pic>
+      <p:sp>
+        <p:nvSpPr>
+          <p:cNvPr id="39" name="Text 30"/>
+          <p:cNvSpPr txBox="1"/>
+          <p:nvPr/>
+        </p:nvSpPr>
+        <p:spPr>
+          <a:xfrm>
+            <a:off x="987552" y="3968496"/>
+            <a:ext cx="1947672" cy="365760"/>
+          </a:xfrm>
+          <a:prstGeom prst="rect">
+            <a:avLst/>
+          </a:prstGeom>
+          <a:noFill/>
+          <a:ln/>
+        </p:spPr>
+        <p:txBody>
+          <a:bodyPr wrap="square" lIns="0" tIns="0" rIns="0" bIns="0" rtlCol="0" anchor="ctr"/>
+          <a:lstStyle/>
+          <a:p>
+            <a:pPr indent="0" marL="0">
+              <a:buNone/>
+            </a:pPr>
+            <a:r>
+              <a:rPr lang="en-US" sz="1250" b="1" dirty="0">
+                <a:solidFill>
+                  <a:srgbClr val="0F172A"/>
+                </a:solidFill>
+                <a:latin typeface="Calibri" pitchFamily="34" charset="0"/>
+                <a:ea typeface="Calibri" pitchFamily="34" charset="-122"/>
+                <a:cs typeface="Calibri" pitchFamily="34" charset="-120"/>
+              </a:rPr>
+              <a:t>Slide Deck</a:t>
+            </a:r>
+            <a:endParaRPr lang="en-US" sz="1250" dirty="0"/>
+          </a:p>
+        </p:txBody>
+      </p:sp>
+      <p:sp>
+        <p:nvSpPr>
+          <p:cNvPr id="40" name="Text 31"/>
+          <p:cNvSpPr txBox="1"/>
+          <p:nvPr/>
+        </p:nvSpPr>
+        <p:spPr>
+          <a:xfrm>
+            <a:off x="585216" y="4334256"/>
+            <a:ext cx="2368296" cy="658368"/>
+          </a:xfrm>
+          <a:prstGeom prst="rect">
+            <a:avLst/>
+          </a:prstGeom>
+          <a:noFill/>
+          <a:ln/>
+        </p:spPr>
+        <p:txBody>
+          <a:bodyPr wrap="square" lIns="0" tIns="0" rIns="0" bIns="0" rtlCol="0" anchor="t"/>
+          <a:lstStyle/>
+          <a:p>
+            <a:pPr indent="0" marL="0">
+              <a:buNone/>
+            </a:pPr>
+            <a:r>
+              <a:rPr lang="en-US" sz="950" dirty="0">
+                <a:solidFill>
+                  <a:srgbClr val="475569"/>
+                </a:solidFill>
+                <a:latin typeface="Calibri" pitchFamily="34" charset="0"/>
+                <a:ea typeface="Calibri" pitchFamily="34" charset="-122"/>
+                <a:cs typeface="Calibri" pitchFamily="34" charset="-120"/>
+              </a:rPr>
+              <a:t>A presentation built from your sources, ready to export.</a:t>
+            </a:r>
+            <a:endParaRPr lang="en-US" sz="950" dirty="0"/>
+          </a:p>
+        </p:txBody>
+      </p:sp>
+      <p:sp>
+        <p:nvSpPr>
+          <p:cNvPr id="41" name="Shape 32"/>
+          <p:cNvSpPr/>
+          <p:nvPr/>
+        </p:nvSpPr>
+        <p:spPr>
+          <a:xfrm>
+            <a:off x="3200400" y="3877056"/>
+            <a:ext cx="2624328" cy="1207008"/>
+          </a:xfrm>
+          <a:prstGeom prst="roundRect">
+            <a:avLst>
+              <a:gd name="adj" fmla="val 9091"/>
+            </a:avLst>
+          </a:prstGeom>
+          <a:solidFill>
+            <a:srgbClr val="F8FAFC"/>
+          </a:solidFill>
+          <a:ln w="12700">
+            <a:solidFill>
+              <a:srgbClr val="E2E8F0"/>
+            </a:solidFill>
+            <a:prstDash val="solid"/>
+          </a:ln>
+        </p:spPr>
+      </p:sp>
+      <p:sp>
+        <p:nvSpPr>
+          <p:cNvPr id="42" name="Shape 33"/>
+          <p:cNvSpPr/>
+          <p:nvPr/>
+        </p:nvSpPr>
+        <p:spPr>
+          <a:xfrm>
+            <a:off x="3328416" y="3986784"/>
+            <a:ext cx="329184" cy="329184"/>
+          </a:xfrm>
+          <a:prstGeom prst="ellipse">
+            <a:avLst/>
+          </a:prstGeom>
+          <a:solidFill>
+            <a:srgbClr val="F1F5F9"/>
+          </a:solidFill>
+          <a:ln w="12700">
+            <a:solidFill>
+              <a:srgbClr val="F1F5F9"/>
+            </a:solidFill>
+            <a:prstDash val="solid"/>
+          </a:ln>
+        </p:spPr>
+      </p:sp>
+      <p:pic>
+        <p:nvPicPr>
+          <p:cNvPr id="43" name="Image 7" descr="preencoded.png">    </p:cNvPr>
+          <p:cNvPicPr>
+            <a:picLocks noChangeAspect="1"/>
+          </p:cNvPicPr>
+          <p:nvPr/>
+        </p:nvPicPr>
+        <p:blipFill>
+          <a:blip r:embed="rId8"/>
+          <a:stretch>
+            <a:fillRect/>
+          </a:stretch>
+        </p:blipFill>
+        <p:spPr>
+          <a:xfrm>
+            <a:off x="3414004" y="4072372"/>
+            <a:ext cx="158008" cy="158008"/>
+          </a:xfrm>
+          <a:prstGeom prst="rect">
+            <a:avLst/>
+          </a:prstGeom>
+        </p:spPr>
+      </p:pic>
+      <p:sp>
+        <p:nvSpPr>
+          <p:cNvPr id="44" name="Text 34"/>
+          <p:cNvSpPr txBox="1"/>
+          <p:nvPr/>
+        </p:nvSpPr>
+        <p:spPr>
+          <a:xfrm>
+            <a:off x="3730752" y="3968496"/>
+            <a:ext cx="1947672" cy="365760"/>
+          </a:xfrm>
+          <a:prstGeom prst="rect">
+            <a:avLst/>
+          </a:prstGeom>
+          <a:noFill/>
+          <a:ln/>
+        </p:spPr>
+        <p:txBody>
+          <a:bodyPr wrap="square" lIns="0" tIns="0" rIns="0" bIns="0" rtlCol="0" anchor="ctr"/>
+          <a:lstStyle/>
+          <a:p>
+            <a:pPr indent="0" marL="0">
+              <a:buNone/>
+            </a:pPr>
+            <a:r>
+              <a:rPr lang="en-US" sz="1250" b="1" dirty="0">
+                <a:solidFill>
+                  <a:srgbClr val="0F172A"/>
+                </a:solidFill>
+                <a:latin typeface="Calibri" pitchFamily="34" charset="0"/>
+                <a:ea typeface="Calibri" pitchFamily="34" charset="-122"/>
+                <a:cs typeface="Calibri" pitchFamily="34" charset="-120"/>
+              </a:rPr>
+              <a:t>Video Overview</a:t>
+            </a:r>
+            <a:endParaRPr lang="en-US" sz="1250" dirty="0"/>
+          </a:p>
+        </p:txBody>
+      </p:sp>
+      <p:sp>
+        <p:nvSpPr>
+          <p:cNvPr id="45" name="Text 35"/>
+          <p:cNvSpPr txBox="1"/>
+          <p:nvPr/>
+        </p:nvSpPr>
+        <p:spPr>
+          <a:xfrm>
+            <a:off x="3328416" y="4334256"/>
+            <a:ext cx="2368296" cy="658368"/>
+          </a:xfrm>
+          <a:prstGeom prst="rect">
+            <a:avLst/>
+          </a:prstGeom>
+          <a:noFill/>
+          <a:ln/>
+        </p:spPr>
+        <p:txBody>
+          <a:bodyPr wrap="square" lIns="0" tIns="0" rIns="0" bIns="0" rtlCol="0" anchor="t"/>
+          <a:lstStyle/>
+          <a:p>
+            <a:pPr indent="0" marL="0">
+              <a:buNone/>
+            </a:pPr>
+            <a:r>
+              <a:rPr lang="en-US" sz="950" dirty="0">
+                <a:solidFill>
+                  <a:srgbClr val="475569"/>
+                </a:solidFill>
+                <a:latin typeface="Calibri" pitchFamily="34" charset="0"/>
+                <a:ea typeface="Calibri" pitchFamily="34" charset="-122"/>
+                <a:cs typeface="Calibri" pitchFamily="34" charset="-120"/>
+              </a:rPr>
+              <a:t>A generated video walkthrough, in a range of visual styles.</a:t>
+            </a:r>
+            <a:endParaRPr lang="en-US" sz="950" dirty="0"/>
+          </a:p>
+        </p:txBody>
+      </p:sp>
+      <p:sp>
+        <p:nvSpPr>
+          <p:cNvPr id="46" name="Shape 36"/>
+          <p:cNvSpPr/>
+          <p:nvPr/>
+        </p:nvSpPr>
+        <p:spPr>
+          <a:xfrm>
+            <a:off x="5943600" y="3877056"/>
+            <a:ext cx="2624328" cy="1207008"/>
+          </a:xfrm>
+          <a:prstGeom prst="roundRect">
+            <a:avLst>
+              <a:gd name="adj" fmla="val 9091"/>
+            </a:avLst>
+          </a:prstGeom>
+          <a:solidFill>
+            <a:srgbClr val="F8FAFC"/>
+          </a:solidFill>
+          <a:ln w="12700">
+            <a:solidFill>
+              <a:srgbClr val="E2E8F0"/>
+            </a:solidFill>
+            <a:prstDash val="solid"/>
+          </a:ln>
+        </p:spPr>
+      </p:sp>
+      <p:sp>
+        <p:nvSpPr>
+          <p:cNvPr id="47" name="Shape 37"/>
+          <p:cNvSpPr/>
+          <p:nvPr/>
+        </p:nvSpPr>
+        <p:spPr>
+          <a:xfrm>
+            <a:off x="6071616" y="3986784"/>
+            <a:ext cx="329184" cy="329184"/>
+          </a:xfrm>
+          <a:prstGeom prst="ellipse">
+            <a:avLst/>
+          </a:prstGeom>
+          <a:solidFill>
+            <a:srgbClr val="F1F5F9"/>
+          </a:solidFill>
+          <a:ln w="12700">
+            <a:solidFill>
+              <a:srgbClr val="F1F5F9"/>
+            </a:solidFill>
+            <a:prstDash val="solid"/>
+          </a:ln>
+        </p:spPr>
+      </p:sp>
+      <p:pic>
+        <p:nvPicPr>
+          <p:cNvPr id="48" name="Image 8" descr="preencoded.png">    </p:cNvPr>
+          <p:cNvPicPr>
+            <a:picLocks noChangeAspect="1"/>
+          </p:cNvPicPr>
+          <p:nvPr/>
+        </p:nvPicPr>
+        <p:blipFill>
+          <a:blip r:embed="rId9"/>
+          <a:stretch>
+            <a:fillRect/>
+          </a:stretch>
+        </p:blipFill>
+        <p:spPr>
+          <a:xfrm>
+            <a:off x="6157204" y="4072372"/>
+            <a:ext cx="158008" cy="158008"/>
+          </a:xfrm>
+          <a:prstGeom prst="rect">
+            <a:avLst/>
+          </a:prstGeom>
+        </p:spPr>
+      </p:pic>
+      <p:sp>
+        <p:nvSpPr>
+          <p:cNvPr id="49" name="Text 38"/>
+          <p:cNvSpPr txBox="1"/>
+          <p:nvPr/>
+        </p:nvSpPr>
+        <p:spPr>
+          <a:xfrm>
+            <a:off x="6473952" y="3968496"/>
+            <a:ext cx="1947672" cy="365760"/>
+          </a:xfrm>
+          <a:prstGeom prst="rect">
+            <a:avLst/>
+          </a:prstGeom>
+          <a:noFill/>
+          <a:ln/>
+        </p:spPr>
+        <p:txBody>
+          <a:bodyPr wrap="square" lIns="0" tIns="0" rIns="0" bIns="0" rtlCol="0" anchor="ctr"/>
+          <a:lstStyle/>
+          <a:p>
+            <a:pPr indent="0" marL="0">
+              <a:buNone/>
+            </a:pPr>
+            <a:r>
+              <a:rPr lang="en-US" sz="1250" b="1" dirty="0">
+                <a:solidFill>
+                  <a:srgbClr val="0F172A"/>
+                </a:solidFill>
+                <a:latin typeface="Calibri" pitchFamily="34" charset="0"/>
+                <a:ea typeface="Calibri" pitchFamily="34" charset="-122"/>
+                <a:cs typeface="Calibri" pitchFamily="34" charset="-120"/>
+              </a:rPr>
+              <a:t>Flashcards</a:t>
+            </a:r>
+            <a:endParaRPr lang="en-US" sz="1250" dirty="0"/>
+          </a:p>
+        </p:txBody>
+      </p:sp>
+      <p:sp>
+        <p:nvSpPr>
+          <p:cNvPr id="50" name="Text 39"/>
+          <p:cNvSpPr txBox="1"/>
+          <p:nvPr/>
+        </p:nvSpPr>
+        <p:spPr>
+          <a:xfrm>
+            <a:off x="6071616" y="4334256"/>
+            <a:ext cx="2368296" cy="658368"/>
+          </a:xfrm>
+          <a:prstGeom prst="rect">
+            <a:avLst/>
+          </a:prstGeom>
+          <a:noFill/>
+          <a:ln/>
+        </p:spPr>
+        <p:txBody>
+          <a:bodyPr wrap="square" lIns="0" tIns="0" rIns="0" bIns="0" rtlCol="0" anchor="t"/>
+          <a:lstStyle/>
+          <a:p>
+            <a:pPr indent="0" marL="0">
+              <a:buNone/>
+            </a:pPr>
+            <a:r>
+              <a:rPr lang="en-US" sz="950" dirty="0">
+                <a:solidFill>
+                  <a:srgbClr val="475569"/>
+                </a:solidFill>
+                <a:latin typeface="Calibri" pitchFamily="34" charset="0"/>
+                <a:ea typeface="Calibri" pitchFamily="34" charset="-122"/>
+                <a:cs typeface="Calibri" pitchFamily="34" charset="-120"/>
+              </a:rPr>
+              <a:t>Term-and-answer cards for self-quizzing, downloadable as a CSV.</a:t>
+            </a:r>
+            <a:endParaRPr lang="en-US" sz="950" dirty="0"/>
           </a:p>
         </p:txBody>
       </p:sp>
@@ -3572,13 +4204,13 @@
             <a:r>
               <a:rPr lang="en-US" sz="1100" b="1" spc="200" kern="0" dirty="0">
                 <a:solidFill>
-                  <a:srgbClr val="7C3AED"/>
-                </a:solidFill>
-                <a:latin typeface="Calibri" pitchFamily="34" charset="0"/>
-                <a:ea typeface="Calibri" pitchFamily="34" charset="-122"/>
-                <a:cs typeface="Calibri" pitchFamily="34" charset="-120"/>
-              </a:rPr>
-              <a:t>SYNTHESIS</a:t>
+                  <a:srgbClr val="059669"/>
+                </a:solidFill>
+                <a:latin typeface="Calibri" pitchFamily="34" charset="0"/>
+                <a:ea typeface="Calibri" pitchFamily="34" charset="-122"/>
+                <a:cs typeface="Calibri" pitchFamily="34" charset="-120"/>
+              </a:rPr>
+              <a:t>GOOGLE COLAB</a:t>
             </a:r>
             <a:endParaRPr lang="en-US" sz="1100" dirty="0"/>
           </a:p>
@@ -3617,7 +4249,7 @@
                 <a:ea typeface="Calibri" pitchFamily="34" charset="-122"/>
                 <a:cs typeface="Calibri" pitchFamily="34" charset="-120"/>
               </a:rPr>
-              <a:t>Underneath all of it, the same two ideas</a:t>
+              <a:t>Other real-life uses</a:t>
             </a:r>
             <a:endParaRPr lang="en-US" sz="2800" dirty="0"/>
           </a:p>
@@ -3631,20 +4263,20 @@
         </p:nvSpPr>
         <p:spPr>
           <a:xfrm>
-            <a:off x="457200" y="1417320"/>
-            <a:ext cx="4023360" cy="2880360"/>
+            <a:off x="457200" y="1371600"/>
+            <a:ext cx="2624328" cy="1554480"/>
           </a:xfrm>
           <a:prstGeom prst="roundRect">
             <a:avLst>
-              <a:gd name="adj" fmla="val 3810"/>
+              <a:gd name="adj" fmla="val 7059"/>
             </a:avLst>
           </a:prstGeom>
           <a:solidFill>
-            <a:srgbClr val="EFF6FF"/>
+            <a:srgbClr val="F8FAFC"/>
           </a:solidFill>
           <a:ln w="12700">
             <a:solidFill>
-              <a:srgbClr val="BFDBFE"/>
+              <a:srgbClr val="E2E8F0"/>
             </a:solidFill>
             <a:prstDash val="solid"/>
           </a:ln>
@@ -3658,18 +4290,18 @@
         </p:nvSpPr>
         <p:spPr>
           <a:xfrm>
-            <a:off x="685800" y="1627632"/>
-            <a:ext cx="502920" cy="502920"/>
+            <a:off x="603504" y="1499616"/>
+            <a:ext cx="384048" cy="384048"/>
           </a:xfrm>
           <a:prstGeom prst="ellipse">
             <a:avLst/>
           </a:prstGeom>
           <a:solidFill>
-            <a:srgbClr val="DBEAFE"/>
+            <a:srgbClr val="D1FAE5"/>
           </a:solidFill>
           <a:ln w="12700">
             <a:solidFill>
-              <a:srgbClr val="DBEAFE"/>
+              <a:srgbClr val="D1FAE5"/>
             </a:solidFill>
             <a:prstDash val="solid"/>
           </a:ln>
@@ -3691,8 +4323,8 @@
         </p:blipFill>
         <p:spPr>
           <a:xfrm>
-            <a:off x="816559" y="1758391"/>
-            <a:ext cx="241402" cy="241402"/>
+            <a:off x="703356" y="1599468"/>
+            <a:ext cx="184343" cy="184343"/>
           </a:xfrm>
           <a:prstGeom prst="rect">
             <a:avLst/>
@@ -3707,8 +4339,8 @@
         </p:nvSpPr>
         <p:spPr>
           <a:xfrm>
-            <a:off x="685800" y="2286000"/>
-            <a:ext cx="3657600" cy="365760"/>
+            <a:off x="1078992" y="1481328"/>
+            <a:ext cx="1847088" cy="420624"/>
           </a:xfrm>
           <a:prstGeom prst="rect">
             <a:avLst/>
@@ -3724,17 +4356,17 @@
               <a:buNone/>
             </a:pPr>
             <a:r>
-              <a:rPr lang="en-US" sz="1900" b="1" dirty="0">
-                <a:solidFill>
-                  <a:srgbClr val="1D4ED8"/>
-                </a:solidFill>
-                <a:latin typeface="Calibri" pitchFamily="34" charset="0"/>
-                <a:ea typeface="Calibri" pitchFamily="34" charset="-122"/>
-                <a:cs typeface="Calibri" pitchFamily="34" charset="-120"/>
-              </a:rPr>
-              <a:t>Grounded answers</a:t>
-            </a:r>
-            <a:endParaRPr lang="en-US" sz="1900" dirty="0"/>
+              <a:rPr lang="en-US" sz="1350" b="1" dirty="0">
+                <a:solidFill>
+                  <a:srgbClr val="0F172A"/>
+                </a:solidFill>
+                <a:latin typeface="Calibri" pitchFamily="34" charset="0"/>
+                <a:ea typeface="Calibri" pitchFamily="34" charset="-122"/>
+                <a:cs typeface="Calibri" pitchFamily="34" charset="-120"/>
+              </a:rPr>
+              <a:t>Data cleaning &amp; EDA</a:t>
+            </a:r>
+            <a:endParaRPr lang="en-US" sz="1350" dirty="0"/>
           </a:p>
         </p:txBody>
       </p:sp>
@@ -3746,47 +4378,8 @@
         </p:nvSpPr>
         <p:spPr>
           <a:xfrm>
-            <a:off x="685800" y="2633472"/>
-            <a:ext cx="3657600" cy="365760"/>
-          </a:xfrm>
-          <a:prstGeom prst="rect">
-            <a:avLst/>
-          </a:prstGeom>
-          <a:noFill/>
-          <a:ln/>
-        </p:spPr>
-        <p:txBody>
-          <a:bodyPr wrap="square" lIns="0" tIns="0" rIns="0" bIns="0" rtlCol="0" anchor="ctr"/>
-          <a:lstStyle/>
-          <a:p>
-            <a:pPr indent="0" marL="0">
-              <a:buNone/>
-            </a:pPr>
-            <a:r>
-              <a:rPr lang="en-US" sz="1900" b="1" dirty="0">
-                <a:solidFill>
-                  <a:srgbClr val="1D4ED8"/>
-                </a:solidFill>
-                <a:latin typeface="Calibri" pitchFamily="34" charset="0"/>
-                <a:ea typeface="Calibri" pitchFamily="34" charset="-122"/>
-                <a:cs typeface="Calibri" pitchFamily="34" charset="-120"/>
-              </a:rPr>
-              <a:t>from your own sources</a:t>
-            </a:r>
-            <a:endParaRPr lang="en-US" sz="1900" dirty="0"/>
-          </a:p>
-        </p:txBody>
-      </p:sp>
-      <p:sp>
-        <p:nvSpPr>
-          <p:cNvPr id="9" name="Text 6"/>
-          <p:cNvSpPr txBox="1"/>
-          <p:nvPr/>
-        </p:nvSpPr>
-        <p:spPr>
-          <a:xfrm>
-            <a:off x="685800" y="3108960"/>
-            <a:ext cx="3657600" cy="1051560"/>
+            <a:off x="603504" y="1938528"/>
+            <a:ext cx="2331720" cy="896112"/>
           </a:xfrm>
           <a:prstGeom prst="rect">
             <a:avLst/>
@@ -3802,42 +4395,42 @@
               <a:buNone/>
             </a:pPr>
             <a:r>
-              <a:rPr lang="en-US" sz="1300" dirty="0">
-                <a:solidFill>
-                  <a:srgbClr val="1E3A8A"/>
-                </a:solidFill>
-                <a:latin typeface="Calibri" pitchFamily="34" charset="0"/>
-                <a:ea typeface="Calibri" pitchFamily="34" charset="-122"/>
-                <a:cs typeface="Calibri" pitchFamily="34" charset="-120"/>
-              </a:rPr>
-              <a:t>Onboarding, contracts, meeting prep, literature reviews, support audits, research, all the same move: point the tool at documents that already exist and demand a citation.</a:t>
-            </a:r>
-            <a:endParaRPr lang="en-US" sz="1300" dirty="0"/>
-          </a:p>
-        </p:txBody>
-      </p:sp>
-      <p:sp>
-        <p:nvSpPr>
-          <p:cNvPr id="10" name="Shape 7"/>
+              <a:rPr lang="en-US" sz="1050" dirty="0">
+                <a:solidFill>
+                  <a:srgbClr val="475569"/>
+                </a:solidFill>
+                <a:latin typeface="Calibri" pitchFamily="34" charset="0"/>
+                <a:ea typeface="Calibri" pitchFamily="34" charset="-122"/>
+                <a:cs typeface="Calibri" pitchFamily="34" charset="-120"/>
+              </a:rPr>
+              <a:t>Upload a messy CSV, profile it, clean it and chart it, the same prompt-to-plot pattern from today's demo.</a:t>
+            </a:r>
+            <a:endParaRPr lang="en-US" sz="1050" dirty="0"/>
+          </a:p>
+        </p:txBody>
+      </p:sp>
+      <p:sp>
+        <p:nvSpPr>
+          <p:cNvPr id="9" name="Shape 6"/>
           <p:cNvSpPr/>
           <p:nvPr/>
         </p:nvSpPr>
         <p:spPr>
           <a:xfrm>
-            <a:off x="4663440" y="1417320"/>
-            <a:ext cx="4023360" cy="2880360"/>
+            <a:off x="3200400" y="1371600"/>
+            <a:ext cx="2624328" cy="1554480"/>
           </a:xfrm>
           <a:prstGeom prst="roundRect">
             <a:avLst>
-              <a:gd name="adj" fmla="val 3810"/>
+              <a:gd name="adj" fmla="val 7059"/>
             </a:avLst>
           </a:prstGeom>
           <a:solidFill>
-            <a:srgbClr val="ECFDF5"/>
+            <a:srgbClr val="F8FAFC"/>
           </a:solidFill>
           <a:ln w="12700">
             <a:solidFill>
-              <a:srgbClr val="A7F3D0"/>
+              <a:srgbClr val="E2E8F0"/>
             </a:solidFill>
             <a:prstDash val="solid"/>
           </a:ln>
@@ -3845,14 +4438,14 @@
       </p:sp>
       <p:sp>
         <p:nvSpPr>
-          <p:cNvPr id="11" name="Shape 8"/>
+          <p:cNvPr id="10" name="Shape 7"/>
           <p:cNvSpPr/>
           <p:nvPr/>
         </p:nvSpPr>
         <p:spPr>
           <a:xfrm>
-            <a:off x="4892040" y="1627632"/>
-            <a:ext cx="502920" cy="502920"/>
+            <a:off x="3346704" y="1499616"/>
+            <a:ext cx="384048" cy="384048"/>
           </a:xfrm>
           <a:prstGeom prst="ellipse">
             <a:avLst/>
@@ -3870,7 +4463,7 @@
       </p:sp>
       <p:pic>
         <p:nvPicPr>
-          <p:cNvPr id="12" name="Image 1" descr="preencoded.png">    </p:cNvPr>
+          <p:cNvPr id="11" name="Image 1" descr="preencoded.png">    </p:cNvPr>
           <p:cNvPicPr>
             <a:picLocks noChangeAspect="1"/>
           </p:cNvPicPr>
@@ -3884,8 +4477,8 @@
         </p:blipFill>
         <p:spPr>
           <a:xfrm>
-            <a:off x="5022799" y="1758391"/>
-            <a:ext cx="241402" cy="241402"/>
+            <a:off x="3446556" y="1599468"/>
+            <a:ext cx="184343" cy="184343"/>
           </a:xfrm>
           <a:prstGeom prst="rect">
             <a:avLst/>
@@ -3894,14 +4487,168 @@
       </p:pic>
       <p:sp>
         <p:nvSpPr>
+          <p:cNvPr id="12" name="Text 8"/>
+          <p:cNvSpPr txBox="1"/>
+          <p:nvPr/>
+        </p:nvSpPr>
+        <p:spPr>
+          <a:xfrm>
+            <a:off x="3822192" y="1481328"/>
+            <a:ext cx="1847088" cy="420624"/>
+          </a:xfrm>
+          <a:prstGeom prst="rect">
+            <a:avLst/>
+          </a:prstGeom>
+          <a:noFill/>
+          <a:ln/>
+        </p:spPr>
+        <p:txBody>
+          <a:bodyPr wrap="square" lIns="0" tIns="0" rIns="0" bIns="0" rtlCol="0" anchor="ctr"/>
+          <a:lstStyle/>
+          <a:p>
+            <a:pPr indent="0" marL="0">
+              <a:buNone/>
+            </a:pPr>
+            <a:r>
+              <a:rPr lang="en-US" sz="1350" b="1" dirty="0">
+                <a:solidFill>
+                  <a:srgbClr val="0F172A"/>
+                </a:solidFill>
+                <a:latin typeface="Calibri" pitchFamily="34" charset="0"/>
+                <a:ea typeface="Calibri" pitchFamily="34" charset="-122"/>
+                <a:cs typeface="Calibri" pitchFamily="34" charset="-120"/>
+              </a:rPr>
+              <a:t>Model prototyping</a:t>
+            </a:r>
+            <a:endParaRPr lang="en-US" sz="1350" dirty="0"/>
+          </a:p>
+        </p:txBody>
+      </p:sp>
+      <p:sp>
+        <p:nvSpPr>
           <p:cNvPr id="13" name="Text 9"/>
           <p:cNvSpPr txBox="1"/>
           <p:nvPr/>
         </p:nvSpPr>
         <p:spPr>
           <a:xfrm>
-            <a:off x="4892040" y="2286000"/>
-            <a:ext cx="3657600" cy="365760"/>
+            <a:off x="3346704" y="1938528"/>
+            <a:ext cx="2331720" cy="896112"/>
+          </a:xfrm>
+          <a:prstGeom prst="rect">
+            <a:avLst/>
+          </a:prstGeom>
+          <a:noFill/>
+          <a:ln/>
+        </p:spPr>
+        <p:txBody>
+          <a:bodyPr wrap="square" lIns="0" tIns="0" rIns="0" bIns="0" rtlCol="0" anchor="t"/>
+          <a:lstStyle/>
+          <a:p>
+            <a:pPr indent="0" marL="0">
+              <a:buNone/>
+            </a:pPr>
+            <a:r>
+              <a:rPr lang="en-US" sz="1050" dirty="0">
+                <a:solidFill>
+                  <a:srgbClr val="475569"/>
+                </a:solidFill>
+                <a:latin typeface="Calibri" pitchFamily="34" charset="0"/>
+                <a:ea typeface="Calibri" pitchFamily="34" charset="-122"/>
+                <a:cs typeface="Calibri" pitchFamily="34" charset="-120"/>
+              </a:rPr>
+              <a:t>Try a small model or a fine-tune on a free GPU before deciding it's worth dedicated infrastructure.</a:t>
+            </a:r>
+            <a:endParaRPr lang="en-US" sz="1050" dirty="0"/>
+          </a:p>
+        </p:txBody>
+      </p:sp>
+      <p:sp>
+        <p:nvSpPr>
+          <p:cNvPr id="14" name="Shape 10"/>
+          <p:cNvSpPr/>
+          <p:nvPr/>
+        </p:nvSpPr>
+        <p:spPr>
+          <a:xfrm>
+            <a:off x="5943600" y="1371600"/>
+            <a:ext cx="2624328" cy="1554480"/>
+          </a:xfrm>
+          <a:prstGeom prst="roundRect">
+            <a:avLst>
+              <a:gd name="adj" fmla="val 7059"/>
+            </a:avLst>
+          </a:prstGeom>
+          <a:solidFill>
+            <a:srgbClr val="F8FAFC"/>
+          </a:solidFill>
+          <a:ln w="12700">
+            <a:solidFill>
+              <a:srgbClr val="E2E8F0"/>
+            </a:solidFill>
+            <a:prstDash val="solid"/>
+          </a:ln>
+        </p:spPr>
+      </p:sp>
+      <p:sp>
+        <p:nvSpPr>
+          <p:cNvPr id="15" name="Shape 11"/>
+          <p:cNvSpPr/>
+          <p:nvPr/>
+        </p:nvSpPr>
+        <p:spPr>
+          <a:xfrm>
+            <a:off x="6089904" y="1499616"/>
+            <a:ext cx="384048" cy="384048"/>
+          </a:xfrm>
+          <a:prstGeom prst="ellipse">
+            <a:avLst/>
+          </a:prstGeom>
+          <a:solidFill>
+            <a:srgbClr val="D1FAE5"/>
+          </a:solidFill>
+          <a:ln w="12700">
+            <a:solidFill>
+              <a:srgbClr val="D1FAE5"/>
+            </a:solidFill>
+            <a:prstDash val="solid"/>
+          </a:ln>
+        </p:spPr>
+      </p:sp>
+      <p:pic>
+        <p:nvPicPr>
+          <p:cNvPr id="16" name="Image 2" descr="preencoded.png">    </p:cNvPr>
+          <p:cNvPicPr>
+            <a:picLocks noChangeAspect="1"/>
+          </p:cNvPicPr>
+          <p:nvPr/>
+        </p:nvPicPr>
+        <p:blipFill>
+          <a:blip r:embed="rId3"/>
+          <a:stretch>
+            <a:fillRect/>
+          </a:stretch>
+        </p:blipFill>
+        <p:spPr>
+          <a:xfrm>
+            <a:off x="6189756" y="1599468"/>
+            <a:ext cx="184343" cy="184343"/>
+          </a:xfrm>
+          <a:prstGeom prst="rect">
+            <a:avLst/>
+          </a:prstGeom>
+        </p:spPr>
+      </p:pic>
+      <p:sp>
+        <p:nvSpPr>
+          <p:cNvPr id="17" name="Text 12"/>
+          <p:cNvSpPr txBox="1"/>
+          <p:nvPr/>
+        </p:nvSpPr>
+        <p:spPr>
+          <a:xfrm>
+            <a:off x="6565392" y="1481328"/>
+            <a:ext cx="1847088" cy="420624"/>
           </a:xfrm>
           <a:prstGeom prst="rect">
             <a:avLst/>
@@ -3917,30 +4664,145 @@
               <a:buNone/>
             </a:pPr>
             <a:r>
-              <a:rPr lang="en-US" sz="1900" b="1" dirty="0">
-                <a:solidFill>
-                  <a:srgbClr val="166534"/>
-                </a:solidFill>
-                <a:latin typeface="Calibri" pitchFamily="34" charset="0"/>
-                <a:ea typeface="Calibri" pitchFamily="34" charset="-122"/>
-                <a:cs typeface="Calibri" pitchFamily="34" charset="-120"/>
-              </a:rPr>
-              <a:t>Disposable compute</a:t>
-            </a:r>
-            <a:endParaRPr lang="en-US" sz="1900" dirty="0"/>
-          </a:p>
-        </p:txBody>
-      </p:sp>
-      <p:sp>
-        <p:nvSpPr>
-          <p:cNvPr id="14" name="Text 10"/>
-          <p:cNvSpPr txBox="1"/>
-          <p:nvPr/>
-        </p:nvSpPr>
-        <p:spPr>
-          <a:xfrm>
-            <a:off x="4892040" y="2633472"/>
-            <a:ext cx="3657600" cy="365760"/>
+              <a:rPr lang="en-US" sz="1350" b="1" dirty="0">
+                <a:solidFill>
+                  <a:srgbClr val="0F172A"/>
+                </a:solidFill>
+                <a:latin typeface="Calibri" pitchFamily="34" charset="0"/>
+                <a:ea typeface="Calibri" pitchFamily="34" charset="-122"/>
+                <a:cs typeface="Calibri" pitchFamily="34" charset="-120"/>
+              </a:rPr>
+              <a:t>Teaching &amp; shared homework</a:t>
+            </a:r>
+            <a:endParaRPr lang="en-US" sz="1350" dirty="0"/>
+          </a:p>
+        </p:txBody>
+      </p:sp>
+      <p:sp>
+        <p:nvSpPr>
+          <p:cNvPr id="18" name="Text 13"/>
+          <p:cNvSpPr txBox="1"/>
+          <p:nvPr/>
+        </p:nvSpPr>
+        <p:spPr>
+          <a:xfrm>
+            <a:off x="6089904" y="1938528"/>
+            <a:ext cx="2331720" cy="896112"/>
+          </a:xfrm>
+          <a:prstGeom prst="rect">
+            <a:avLst/>
+          </a:prstGeom>
+          <a:noFill/>
+          <a:ln/>
+        </p:spPr>
+        <p:txBody>
+          <a:bodyPr wrap="square" lIns="0" tIns="0" rIns="0" bIns="0" rtlCol="0" anchor="t"/>
+          <a:lstStyle/>
+          <a:p>
+            <a:pPr indent="0" marL="0">
+              <a:buNone/>
+            </a:pPr>
+            <a:r>
+              <a:rPr lang="en-US" sz="1050" dirty="0">
+                <a:solidFill>
+                  <a:srgbClr val="475569"/>
+                </a:solidFill>
+                <a:latin typeface="Calibri" pitchFamily="34" charset="0"/>
+                <a:ea typeface="Calibri" pitchFamily="34" charset="-122"/>
+                <a:cs typeface="Calibri" pitchFamily="34" charset="-120"/>
+              </a:rPr>
+              <a:t>Share one notebook link so every student runs identical code with zero setup.</a:t>
+            </a:r>
+            <a:endParaRPr lang="en-US" sz="1050" dirty="0"/>
+          </a:p>
+        </p:txBody>
+      </p:sp>
+      <p:sp>
+        <p:nvSpPr>
+          <p:cNvPr id="19" name="Shape 14"/>
+          <p:cNvSpPr/>
+          <p:nvPr/>
+        </p:nvSpPr>
+        <p:spPr>
+          <a:xfrm>
+            <a:off x="457200" y="3063240"/>
+            <a:ext cx="2624328" cy="1554480"/>
+          </a:xfrm>
+          <a:prstGeom prst="roundRect">
+            <a:avLst>
+              <a:gd name="adj" fmla="val 7059"/>
+            </a:avLst>
+          </a:prstGeom>
+          <a:solidFill>
+            <a:srgbClr val="F8FAFC"/>
+          </a:solidFill>
+          <a:ln w="12700">
+            <a:solidFill>
+              <a:srgbClr val="E2E8F0"/>
+            </a:solidFill>
+            <a:prstDash val="solid"/>
+          </a:ln>
+        </p:spPr>
+      </p:sp>
+      <p:sp>
+        <p:nvSpPr>
+          <p:cNvPr id="20" name="Shape 15"/>
+          <p:cNvSpPr/>
+          <p:nvPr/>
+        </p:nvSpPr>
+        <p:spPr>
+          <a:xfrm>
+            <a:off x="603504" y="3191256"/>
+            <a:ext cx="384048" cy="384048"/>
+          </a:xfrm>
+          <a:prstGeom prst="ellipse">
+            <a:avLst/>
+          </a:prstGeom>
+          <a:solidFill>
+            <a:srgbClr val="D1FAE5"/>
+          </a:solidFill>
+          <a:ln w="12700">
+            <a:solidFill>
+              <a:srgbClr val="D1FAE5"/>
+            </a:solidFill>
+            <a:prstDash val="solid"/>
+          </a:ln>
+        </p:spPr>
+      </p:sp>
+      <p:pic>
+        <p:nvPicPr>
+          <p:cNvPr id="21" name="Image 3" descr="preencoded.png">    </p:cNvPr>
+          <p:cNvPicPr>
+            <a:picLocks noChangeAspect="1"/>
+          </p:cNvPicPr>
+          <p:nvPr/>
+        </p:nvPicPr>
+        <p:blipFill>
+          <a:blip r:embed="rId4"/>
+          <a:stretch>
+            <a:fillRect/>
+          </a:stretch>
+        </p:blipFill>
+        <p:spPr>
+          <a:xfrm>
+            <a:off x="703356" y="3291108"/>
+            <a:ext cx="184343" cy="184343"/>
+          </a:xfrm>
+          <a:prstGeom prst="rect">
+            <a:avLst/>
+          </a:prstGeom>
+        </p:spPr>
+      </p:pic>
+      <p:sp>
+        <p:nvSpPr>
+          <p:cNvPr id="22" name="Text 16"/>
+          <p:cNvSpPr txBox="1"/>
+          <p:nvPr/>
+        </p:nvSpPr>
+        <p:spPr>
+          <a:xfrm>
+            <a:off x="1078992" y="3172968"/>
+            <a:ext cx="1847088" cy="420624"/>
           </a:xfrm>
           <a:prstGeom prst="rect">
             <a:avLst/>
@@ -3956,30 +4818,30 @@
               <a:buNone/>
             </a:pPr>
             <a:r>
-              <a:rPr lang="en-US" sz="1900" b="1" dirty="0">
-                <a:solidFill>
-                  <a:srgbClr val="166534"/>
-                </a:solidFill>
-                <a:latin typeface="Calibri" pitchFamily="34" charset="0"/>
-                <a:ea typeface="Calibri" pitchFamily="34" charset="-122"/>
-                <a:cs typeface="Calibri" pitchFamily="34" charset="-120"/>
-              </a:rPr>
-              <a:t>you don't have to own</a:t>
-            </a:r>
-            <a:endParaRPr lang="en-US" sz="1900" dirty="0"/>
-          </a:p>
-        </p:txBody>
-      </p:sp>
-      <p:sp>
-        <p:nvSpPr>
-          <p:cNvPr id="15" name="Text 11"/>
-          <p:cNvSpPr txBox="1"/>
-          <p:nvPr/>
-        </p:nvSpPr>
-        <p:spPr>
-          <a:xfrm>
-            <a:off x="4892040" y="3108960"/>
-            <a:ext cx="3657600" cy="1051560"/>
+              <a:rPr lang="en-US" sz="1350" b="1" dirty="0">
+                <a:solidFill>
+                  <a:srgbClr val="0F172A"/>
+                </a:solidFill>
+                <a:latin typeface="Calibri" pitchFamily="34" charset="0"/>
+                <a:ea typeface="Calibri" pitchFamily="34" charset="-122"/>
+                <a:cs typeface="Calibri" pitchFamily="34" charset="-120"/>
+              </a:rPr>
+              <a:t>One-off automation</a:t>
+            </a:r>
+            <a:endParaRPr lang="en-US" sz="1350" dirty="0"/>
+          </a:p>
+        </p:txBody>
+      </p:sp>
+      <p:sp>
+        <p:nvSpPr>
+          <p:cNvPr id="23" name="Text 17"/>
+          <p:cNvSpPr txBox="1"/>
+          <p:nvPr/>
+        </p:nvSpPr>
+        <p:spPr>
+          <a:xfrm>
+            <a:off x="603504" y="3630168"/>
+            <a:ext cx="2331720" cy="896112"/>
           </a:xfrm>
           <a:prstGeom prst="rect">
             <a:avLst/>
@@ -3995,17 +4857,325 @@
               <a:buNone/>
             </a:pPr>
             <a:r>
-              <a:rPr lang="en-US" sz="1300" dirty="0">
-                <a:solidFill>
-                  <a:srgbClr val="14532D"/>
-                </a:solidFill>
-                <a:latin typeface="Calibri" pitchFamily="34" charset="0"/>
-                <a:ea typeface="Calibri" pitchFamily="34" charset="-122"/>
-                <a:cs typeface="Calibri" pitchFamily="34" charset="-120"/>
-              </a:rPr>
-              <a:t>Cleaning data, prototyping, teaching, automation, debugging together, all the same move: spin up a machine for as long as the task needs, then let it go.</a:t>
-            </a:r>
-            <a:endParaRPr lang="en-US" sz="1300" dirty="0"/>
+              <a:rPr lang="en-US" sz="1050" dirty="0">
+                <a:solidFill>
+                  <a:srgbClr val="475569"/>
+                </a:solidFill>
+                <a:latin typeface="Calibri" pitchFamily="34" charset="0"/>
+                <a:ea typeface="Calibri" pitchFamily="34" charset="-122"/>
+                <a:cs typeface="Calibri" pitchFamily="34" charset="-120"/>
+              </a:rPr>
+              <a:t>A scrape-and-report script that runs occasionally and doesn't justify its own server.</a:t>
+            </a:r>
+            <a:endParaRPr lang="en-US" sz="1050" dirty="0"/>
+          </a:p>
+        </p:txBody>
+      </p:sp>
+      <p:sp>
+        <p:nvSpPr>
+          <p:cNvPr id="24" name="Shape 18"/>
+          <p:cNvSpPr/>
+          <p:nvPr/>
+        </p:nvSpPr>
+        <p:spPr>
+          <a:xfrm>
+            <a:off x="3200400" y="3063240"/>
+            <a:ext cx="2624328" cy="1554480"/>
+          </a:xfrm>
+          <a:prstGeom prst="roundRect">
+            <a:avLst>
+              <a:gd name="adj" fmla="val 7059"/>
+            </a:avLst>
+          </a:prstGeom>
+          <a:solidFill>
+            <a:srgbClr val="F8FAFC"/>
+          </a:solidFill>
+          <a:ln w="12700">
+            <a:solidFill>
+              <a:srgbClr val="E2E8F0"/>
+            </a:solidFill>
+            <a:prstDash val="solid"/>
+          </a:ln>
+        </p:spPr>
+      </p:sp>
+      <p:sp>
+        <p:nvSpPr>
+          <p:cNvPr id="25" name="Shape 19"/>
+          <p:cNvSpPr/>
+          <p:nvPr/>
+        </p:nvSpPr>
+        <p:spPr>
+          <a:xfrm>
+            <a:off x="3346704" y="3191256"/>
+            <a:ext cx="384048" cy="384048"/>
+          </a:xfrm>
+          <a:prstGeom prst="ellipse">
+            <a:avLst/>
+          </a:prstGeom>
+          <a:solidFill>
+            <a:srgbClr val="D1FAE5"/>
+          </a:solidFill>
+          <a:ln w="12700">
+            <a:solidFill>
+              <a:srgbClr val="D1FAE5"/>
+            </a:solidFill>
+            <a:prstDash val="solid"/>
+          </a:ln>
+        </p:spPr>
+      </p:sp>
+      <p:pic>
+        <p:nvPicPr>
+          <p:cNvPr id="26" name="Image 4" descr="preencoded.png">    </p:cNvPr>
+          <p:cNvPicPr>
+            <a:picLocks noChangeAspect="1"/>
+          </p:cNvPicPr>
+          <p:nvPr/>
+        </p:nvPicPr>
+        <p:blipFill>
+          <a:blip r:embed="rId5"/>
+          <a:stretch>
+            <a:fillRect/>
+          </a:stretch>
+        </p:blipFill>
+        <p:spPr>
+          <a:xfrm>
+            <a:off x="3446556" y="3291108"/>
+            <a:ext cx="184343" cy="184343"/>
+          </a:xfrm>
+          <a:prstGeom prst="rect">
+            <a:avLst/>
+          </a:prstGeom>
+        </p:spPr>
+      </p:pic>
+      <p:sp>
+        <p:nvSpPr>
+          <p:cNvPr id="27" name="Text 20"/>
+          <p:cNvSpPr txBox="1"/>
+          <p:nvPr/>
+        </p:nvSpPr>
+        <p:spPr>
+          <a:xfrm>
+            <a:off x="3822192" y="3172968"/>
+            <a:ext cx="1847088" cy="420624"/>
+          </a:xfrm>
+          <a:prstGeom prst="rect">
+            <a:avLst/>
+          </a:prstGeom>
+          <a:noFill/>
+          <a:ln/>
+        </p:spPr>
+        <p:txBody>
+          <a:bodyPr wrap="square" lIns="0" tIns="0" rIns="0" bIns="0" rtlCol="0" anchor="ctr"/>
+          <a:lstStyle/>
+          <a:p>
+            <a:pPr indent="0" marL="0">
+              <a:buNone/>
+            </a:pPr>
+            <a:r>
+              <a:rPr lang="en-US" sz="1350" b="1" dirty="0">
+                <a:solidFill>
+                  <a:srgbClr val="0F172A"/>
+                </a:solidFill>
+                <a:latin typeface="Calibri" pitchFamily="34" charset="0"/>
+                <a:ea typeface="Calibri" pitchFamily="34" charset="-122"/>
+                <a:cs typeface="Calibri" pitchFamily="34" charset="-120"/>
+              </a:rPr>
+              <a:t>Collaborative debugging</a:t>
+            </a:r>
+            <a:endParaRPr lang="en-US" sz="1350" dirty="0"/>
+          </a:p>
+        </p:txBody>
+      </p:sp>
+      <p:sp>
+        <p:nvSpPr>
+          <p:cNvPr id="28" name="Text 21"/>
+          <p:cNvSpPr txBox="1"/>
+          <p:nvPr/>
+        </p:nvSpPr>
+        <p:spPr>
+          <a:xfrm>
+            <a:off x="3346704" y="3630168"/>
+            <a:ext cx="2331720" cy="896112"/>
+          </a:xfrm>
+          <a:prstGeom prst="rect">
+            <a:avLst/>
+          </a:prstGeom>
+          <a:noFill/>
+          <a:ln/>
+        </p:spPr>
+        <p:txBody>
+          <a:bodyPr wrap="square" lIns="0" tIns="0" rIns="0" bIns="0" rtlCol="0" anchor="t"/>
+          <a:lstStyle/>
+          <a:p>
+            <a:pPr indent="0" marL="0">
+              <a:buNone/>
+            </a:pPr>
+            <a:r>
+              <a:rPr lang="en-US" sz="1050" dirty="0">
+                <a:solidFill>
+                  <a:srgbClr val="475569"/>
+                </a:solidFill>
+                <a:latin typeface="Calibri" pitchFamily="34" charset="0"/>
+                <a:ea typeface="Calibri" pitchFamily="34" charset="-122"/>
+                <a:cs typeface="Calibri" pitchFamily="34" charset="-120"/>
+              </a:rPr>
+              <a:t>Two people open the same notebook; one triggers an error, the other reviews the suggested fix.</a:t>
+            </a:r>
+            <a:endParaRPr lang="en-US" sz="1050" dirty="0"/>
+          </a:p>
+        </p:txBody>
+      </p:sp>
+      <p:sp>
+        <p:nvSpPr>
+          <p:cNvPr id="29" name="Shape 22"/>
+          <p:cNvSpPr/>
+          <p:nvPr/>
+        </p:nvSpPr>
+        <p:spPr>
+          <a:xfrm>
+            <a:off x="5943600" y="3063240"/>
+            <a:ext cx="2624328" cy="1554480"/>
+          </a:xfrm>
+          <a:prstGeom prst="roundRect">
+            <a:avLst>
+              <a:gd name="adj" fmla="val 7059"/>
+            </a:avLst>
+          </a:prstGeom>
+          <a:solidFill>
+            <a:srgbClr val="FFFBEB"/>
+          </a:solidFill>
+          <a:ln w="12700">
+            <a:solidFill>
+              <a:srgbClr val="FDE68A"/>
+            </a:solidFill>
+            <a:prstDash val="solid"/>
+          </a:ln>
+        </p:spPr>
+      </p:sp>
+      <p:sp>
+        <p:nvSpPr>
+          <p:cNvPr id="30" name="Shape 23"/>
+          <p:cNvSpPr/>
+          <p:nvPr/>
+        </p:nvSpPr>
+        <p:spPr>
+          <a:xfrm>
+            <a:off x="6089904" y="3191256"/>
+            <a:ext cx="384048" cy="384048"/>
+          </a:xfrm>
+          <a:prstGeom prst="ellipse">
+            <a:avLst/>
+          </a:prstGeom>
+          <a:solidFill>
+            <a:srgbClr val="FEF3C7"/>
+          </a:solidFill>
+          <a:ln w="12700">
+            <a:solidFill>
+              <a:srgbClr val="FEF3C7"/>
+            </a:solidFill>
+            <a:prstDash val="solid"/>
+          </a:ln>
+        </p:spPr>
+      </p:sp>
+      <p:pic>
+        <p:nvPicPr>
+          <p:cNvPr id="31" name="Image 5" descr="preencoded.png">    </p:cNvPr>
+          <p:cNvPicPr>
+            <a:picLocks noChangeAspect="1"/>
+          </p:cNvPicPr>
+          <p:nvPr/>
+        </p:nvPicPr>
+        <p:blipFill>
+          <a:blip r:embed="rId6"/>
+          <a:stretch>
+            <a:fillRect/>
+          </a:stretch>
+        </p:blipFill>
+        <p:spPr>
+          <a:xfrm>
+            <a:off x="6189756" y="3291108"/>
+            <a:ext cx="184343" cy="184343"/>
+          </a:xfrm>
+          <a:prstGeom prst="rect">
+            <a:avLst/>
+          </a:prstGeom>
+        </p:spPr>
+      </p:pic>
+      <p:sp>
+        <p:nvSpPr>
+          <p:cNvPr id="32" name="Text 24"/>
+          <p:cNvSpPr txBox="1"/>
+          <p:nvPr/>
+        </p:nvSpPr>
+        <p:spPr>
+          <a:xfrm>
+            <a:off x="6565392" y="3172968"/>
+            <a:ext cx="1847088" cy="420624"/>
+          </a:xfrm>
+          <a:prstGeom prst="rect">
+            <a:avLst/>
+          </a:prstGeom>
+          <a:noFill/>
+          <a:ln/>
+        </p:spPr>
+        <p:txBody>
+          <a:bodyPr wrap="square" lIns="0" tIns="0" rIns="0" bIns="0" rtlCol="0" anchor="ctr"/>
+          <a:lstStyle/>
+          <a:p>
+            <a:pPr indent="0" marL="0">
+              <a:buNone/>
+            </a:pPr>
+            <a:r>
+              <a:rPr lang="en-US" sz="1350" b="1" dirty="0">
+                <a:solidFill>
+                  <a:srgbClr val="78350F"/>
+                </a:solidFill>
+                <a:latin typeface="Calibri" pitchFamily="34" charset="0"/>
+                <a:ea typeface="Calibri" pitchFamily="34" charset="-122"/>
+                <a:cs typeface="Calibri" pitchFamily="34" charset="-120"/>
+              </a:rPr>
+              <a:t>Your turn</a:t>
+            </a:r>
+            <a:endParaRPr lang="en-US" sz="1350" dirty="0"/>
+          </a:p>
+        </p:txBody>
+      </p:sp>
+      <p:sp>
+        <p:nvSpPr>
+          <p:cNvPr id="33" name="Text 25"/>
+          <p:cNvSpPr txBox="1"/>
+          <p:nvPr/>
+        </p:nvSpPr>
+        <p:spPr>
+          <a:xfrm>
+            <a:off x="6089904" y="3630168"/>
+            <a:ext cx="2331720" cy="896112"/>
+          </a:xfrm>
+          <a:prstGeom prst="rect">
+            <a:avLst/>
+          </a:prstGeom>
+          <a:noFill/>
+          <a:ln/>
+        </p:spPr>
+        <p:txBody>
+          <a:bodyPr wrap="square" lIns="0" tIns="0" rIns="0" bIns="0" rtlCol="0" anchor="t"/>
+          <a:lstStyle/>
+          <a:p>
+            <a:pPr indent="0" marL="0">
+              <a:buNone/>
+            </a:pPr>
+            <a:r>
+              <a:rPr lang="en-US" sz="1050" i="1" dirty="0">
+                <a:solidFill>
+                  <a:srgbClr val="78350F"/>
+                </a:solidFill>
+                <a:latin typeface="Calibri" pitchFamily="34" charset="0"/>
+                <a:ea typeface="Calibri" pitchFamily="34" charset="-122"/>
+                <a:cs typeface="Calibri" pitchFamily="34" charset="-120"/>
+              </a:rPr>
+              <a:t>What's a script or analysis you avoid because setting it up feels like too much work?</a:t>
+            </a:r>
+            <a:endParaRPr lang="en-US" sz="1050" dirty="0"/>
           </a:p>
         </p:txBody>
       </p:sp>
@@ -4020,6 +5190,502 @@
 <file path=ppt/slides/slide5.xml><?xml version="1.0" encoding="utf-8"?>
 <p:sld xmlns:a="http://schemas.openxmlformats.org/drawingml/2006/main" xmlns:r="http://schemas.openxmlformats.org/officeDocument/2006/relationships" xmlns:p="http://schemas.openxmlformats.org/presentationml/2006/main">
   <p:cSld name="Slide 5">
+    <p:bg>
+      <p:bgPr>
+        <a:solidFill>
+          <a:srgbClr val="FFFFFF"/>
+        </a:solidFill>
+      </p:bgPr>
+    </p:bg>
+    <p:spTree>
+      <p:nvGrpSpPr>
+        <p:cNvPr id="1" name=""/>
+        <p:cNvGrpSpPr/>
+        <p:nvPr/>
+      </p:nvGrpSpPr>
+      <p:grpSpPr>
+        <a:xfrm>
+          <a:off x="0" y="0"/>
+          <a:ext cx="0" cy="0"/>
+          <a:chOff x="0" y="0"/>
+          <a:chExt cx="0" cy="0"/>
+        </a:xfrm>
+      </p:grpSpPr>
+      <p:sp>
+        <p:nvSpPr>
+          <p:cNvPr id="2" name="Text 0"/>
+          <p:cNvSpPr txBox="1"/>
+          <p:nvPr/>
+        </p:nvSpPr>
+        <p:spPr>
+          <a:xfrm>
+            <a:off x="457200" y="274320"/>
+            <a:ext cx="8229600" cy="274320"/>
+          </a:xfrm>
+          <a:prstGeom prst="rect">
+            <a:avLst/>
+          </a:prstGeom>
+          <a:noFill/>
+          <a:ln/>
+        </p:spPr>
+        <p:txBody>
+          <a:bodyPr wrap="square" lIns="0" tIns="0" rIns="0" bIns="0" rtlCol="0" anchor="ctr"/>
+          <a:lstStyle/>
+          <a:p>
+            <a:pPr indent="0" marL="0">
+              <a:buNone/>
+            </a:pPr>
+            <a:r>
+              <a:rPr lang="en-US" sz="1100" b="1" spc="200" kern="0" dirty="0">
+                <a:solidFill>
+                  <a:srgbClr val="7C3AED"/>
+                </a:solidFill>
+                <a:latin typeface="Calibri" pitchFamily="34" charset="0"/>
+                <a:ea typeface="Calibri" pitchFamily="34" charset="-122"/>
+                <a:cs typeface="Calibri" pitchFamily="34" charset="-120"/>
+              </a:rPr>
+              <a:t>SYNTHESIS</a:t>
+            </a:r>
+            <a:endParaRPr lang="en-US" sz="1100" dirty="0"/>
+          </a:p>
+        </p:txBody>
+      </p:sp>
+      <p:sp>
+        <p:nvSpPr>
+          <p:cNvPr id="3" name="Text 1"/>
+          <p:cNvSpPr txBox="1"/>
+          <p:nvPr/>
+        </p:nvSpPr>
+        <p:spPr>
+          <a:xfrm>
+            <a:off x="457200" y="566928"/>
+            <a:ext cx="8229600" cy="594360"/>
+          </a:xfrm>
+          <a:prstGeom prst="rect">
+            <a:avLst/>
+          </a:prstGeom>
+          <a:noFill/>
+          <a:ln/>
+        </p:spPr>
+        <p:txBody>
+          <a:bodyPr wrap="square" lIns="0" tIns="0" rIns="0" bIns="0" rtlCol="0" anchor="ctr"/>
+          <a:lstStyle/>
+          <a:p>
+            <a:pPr indent="0" marL="0">
+              <a:buNone/>
+            </a:pPr>
+            <a:r>
+              <a:rPr lang="en-US" sz="2800" b="1" dirty="0">
+                <a:solidFill>
+                  <a:srgbClr val="0F172A"/>
+                </a:solidFill>
+                <a:latin typeface="Calibri" pitchFamily="34" charset="0"/>
+                <a:ea typeface="Calibri" pitchFamily="34" charset="-122"/>
+                <a:cs typeface="Calibri" pitchFamily="34" charset="-120"/>
+              </a:rPr>
+              <a:t>Underneath all of it, the same two ideas</a:t>
+            </a:r>
+            <a:endParaRPr lang="en-US" sz="2800" dirty="0"/>
+          </a:p>
+        </p:txBody>
+      </p:sp>
+      <p:sp>
+        <p:nvSpPr>
+          <p:cNvPr id="4" name="Shape 2"/>
+          <p:cNvSpPr/>
+          <p:nvPr/>
+        </p:nvSpPr>
+        <p:spPr>
+          <a:xfrm>
+            <a:off x="457200" y="1417320"/>
+            <a:ext cx="4023360" cy="2880360"/>
+          </a:xfrm>
+          <a:prstGeom prst="roundRect">
+            <a:avLst>
+              <a:gd name="adj" fmla="val 3810"/>
+            </a:avLst>
+          </a:prstGeom>
+          <a:solidFill>
+            <a:srgbClr val="EFF6FF"/>
+          </a:solidFill>
+          <a:ln w="12700">
+            <a:solidFill>
+              <a:srgbClr val="BFDBFE"/>
+            </a:solidFill>
+            <a:prstDash val="solid"/>
+          </a:ln>
+        </p:spPr>
+      </p:sp>
+      <p:sp>
+        <p:nvSpPr>
+          <p:cNvPr id="5" name="Shape 3"/>
+          <p:cNvSpPr/>
+          <p:nvPr/>
+        </p:nvSpPr>
+        <p:spPr>
+          <a:xfrm>
+            <a:off x="685800" y="1627632"/>
+            <a:ext cx="502920" cy="502920"/>
+          </a:xfrm>
+          <a:prstGeom prst="ellipse">
+            <a:avLst/>
+          </a:prstGeom>
+          <a:solidFill>
+            <a:srgbClr val="DBEAFE"/>
+          </a:solidFill>
+          <a:ln w="12700">
+            <a:solidFill>
+              <a:srgbClr val="DBEAFE"/>
+            </a:solidFill>
+            <a:prstDash val="solid"/>
+          </a:ln>
+        </p:spPr>
+      </p:sp>
+      <p:pic>
+        <p:nvPicPr>
+          <p:cNvPr id="6" name="Image 0" descr="preencoded.png">    </p:cNvPr>
+          <p:cNvPicPr>
+            <a:picLocks noChangeAspect="1"/>
+          </p:cNvPicPr>
+          <p:nvPr/>
+        </p:nvPicPr>
+        <p:blipFill>
+          <a:blip r:embed="rId1"/>
+          <a:stretch>
+            <a:fillRect/>
+          </a:stretch>
+        </p:blipFill>
+        <p:spPr>
+          <a:xfrm>
+            <a:off x="816559" y="1758391"/>
+            <a:ext cx="241402" cy="241402"/>
+          </a:xfrm>
+          <a:prstGeom prst="rect">
+            <a:avLst/>
+          </a:prstGeom>
+        </p:spPr>
+      </p:pic>
+      <p:sp>
+        <p:nvSpPr>
+          <p:cNvPr id="7" name="Text 4"/>
+          <p:cNvSpPr txBox="1"/>
+          <p:nvPr/>
+        </p:nvSpPr>
+        <p:spPr>
+          <a:xfrm>
+            <a:off x="685800" y="2286000"/>
+            <a:ext cx="3657600" cy="365760"/>
+          </a:xfrm>
+          <a:prstGeom prst="rect">
+            <a:avLst/>
+          </a:prstGeom>
+          <a:noFill/>
+          <a:ln/>
+        </p:spPr>
+        <p:txBody>
+          <a:bodyPr wrap="square" lIns="0" tIns="0" rIns="0" bIns="0" rtlCol="0" anchor="ctr"/>
+          <a:lstStyle/>
+          <a:p>
+            <a:pPr indent="0" marL="0">
+              <a:buNone/>
+            </a:pPr>
+            <a:r>
+              <a:rPr lang="en-US" sz="1900" b="1" dirty="0">
+                <a:solidFill>
+                  <a:srgbClr val="1D4ED8"/>
+                </a:solidFill>
+                <a:latin typeface="Calibri" pitchFamily="34" charset="0"/>
+                <a:ea typeface="Calibri" pitchFamily="34" charset="-122"/>
+                <a:cs typeface="Calibri" pitchFamily="34" charset="-120"/>
+              </a:rPr>
+              <a:t>Grounded answers</a:t>
+            </a:r>
+            <a:endParaRPr lang="en-US" sz="1900" dirty="0"/>
+          </a:p>
+        </p:txBody>
+      </p:sp>
+      <p:sp>
+        <p:nvSpPr>
+          <p:cNvPr id="8" name="Text 5"/>
+          <p:cNvSpPr txBox="1"/>
+          <p:nvPr/>
+        </p:nvSpPr>
+        <p:spPr>
+          <a:xfrm>
+            <a:off x="685800" y="2633472"/>
+            <a:ext cx="3657600" cy="365760"/>
+          </a:xfrm>
+          <a:prstGeom prst="rect">
+            <a:avLst/>
+          </a:prstGeom>
+          <a:noFill/>
+          <a:ln/>
+        </p:spPr>
+        <p:txBody>
+          <a:bodyPr wrap="square" lIns="0" tIns="0" rIns="0" bIns="0" rtlCol="0" anchor="ctr"/>
+          <a:lstStyle/>
+          <a:p>
+            <a:pPr indent="0" marL="0">
+              <a:buNone/>
+            </a:pPr>
+            <a:r>
+              <a:rPr lang="en-US" sz="1900" b="1" dirty="0">
+                <a:solidFill>
+                  <a:srgbClr val="1D4ED8"/>
+                </a:solidFill>
+                <a:latin typeface="Calibri" pitchFamily="34" charset="0"/>
+                <a:ea typeface="Calibri" pitchFamily="34" charset="-122"/>
+                <a:cs typeface="Calibri" pitchFamily="34" charset="-120"/>
+              </a:rPr>
+              <a:t>from your own sources</a:t>
+            </a:r>
+            <a:endParaRPr lang="en-US" sz="1900" dirty="0"/>
+          </a:p>
+        </p:txBody>
+      </p:sp>
+      <p:sp>
+        <p:nvSpPr>
+          <p:cNvPr id="9" name="Text 6"/>
+          <p:cNvSpPr txBox="1"/>
+          <p:nvPr/>
+        </p:nvSpPr>
+        <p:spPr>
+          <a:xfrm>
+            <a:off x="685800" y="3108960"/>
+            <a:ext cx="3657600" cy="1051560"/>
+          </a:xfrm>
+          <a:prstGeom prst="rect">
+            <a:avLst/>
+          </a:prstGeom>
+          <a:noFill/>
+          <a:ln/>
+        </p:spPr>
+        <p:txBody>
+          <a:bodyPr wrap="square" lIns="0" tIns="0" rIns="0" bIns="0" rtlCol="0" anchor="t"/>
+          <a:lstStyle/>
+          <a:p>
+            <a:pPr indent="0" marL="0">
+              <a:buNone/>
+            </a:pPr>
+            <a:r>
+              <a:rPr lang="en-US" sz="1300" dirty="0">
+                <a:solidFill>
+                  <a:srgbClr val="1E3A8A"/>
+                </a:solidFill>
+                <a:latin typeface="Calibri" pitchFamily="34" charset="0"/>
+                <a:ea typeface="Calibri" pitchFamily="34" charset="-122"/>
+                <a:cs typeface="Calibri" pitchFamily="34" charset="-120"/>
+              </a:rPr>
+              <a:t>Onboarding, contracts, meeting prep, literature reviews, support audits, research, all the same move: point the tool at documents that already exist and demand a citation.</a:t>
+            </a:r>
+            <a:endParaRPr lang="en-US" sz="1300" dirty="0"/>
+          </a:p>
+        </p:txBody>
+      </p:sp>
+      <p:sp>
+        <p:nvSpPr>
+          <p:cNvPr id="10" name="Shape 7"/>
+          <p:cNvSpPr/>
+          <p:nvPr/>
+        </p:nvSpPr>
+        <p:spPr>
+          <a:xfrm>
+            <a:off x="4663440" y="1417320"/>
+            <a:ext cx="4023360" cy="2880360"/>
+          </a:xfrm>
+          <a:prstGeom prst="roundRect">
+            <a:avLst>
+              <a:gd name="adj" fmla="val 3810"/>
+            </a:avLst>
+          </a:prstGeom>
+          <a:solidFill>
+            <a:srgbClr val="ECFDF5"/>
+          </a:solidFill>
+          <a:ln w="12700">
+            <a:solidFill>
+              <a:srgbClr val="A7F3D0"/>
+            </a:solidFill>
+            <a:prstDash val="solid"/>
+          </a:ln>
+        </p:spPr>
+      </p:sp>
+      <p:sp>
+        <p:nvSpPr>
+          <p:cNvPr id="11" name="Shape 8"/>
+          <p:cNvSpPr/>
+          <p:nvPr/>
+        </p:nvSpPr>
+        <p:spPr>
+          <a:xfrm>
+            <a:off x="4892040" y="1627632"/>
+            <a:ext cx="502920" cy="502920"/>
+          </a:xfrm>
+          <a:prstGeom prst="ellipse">
+            <a:avLst/>
+          </a:prstGeom>
+          <a:solidFill>
+            <a:srgbClr val="D1FAE5"/>
+          </a:solidFill>
+          <a:ln w="12700">
+            <a:solidFill>
+              <a:srgbClr val="D1FAE5"/>
+            </a:solidFill>
+            <a:prstDash val="solid"/>
+          </a:ln>
+        </p:spPr>
+      </p:sp>
+      <p:pic>
+        <p:nvPicPr>
+          <p:cNvPr id="12" name="Image 1" descr="preencoded.png">    </p:cNvPr>
+          <p:cNvPicPr>
+            <a:picLocks noChangeAspect="1"/>
+          </p:cNvPicPr>
+          <p:nvPr/>
+        </p:nvPicPr>
+        <p:blipFill>
+          <a:blip r:embed="rId2"/>
+          <a:stretch>
+            <a:fillRect/>
+          </a:stretch>
+        </p:blipFill>
+        <p:spPr>
+          <a:xfrm>
+            <a:off x="5022799" y="1758391"/>
+            <a:ext cx="241402" cy="241402"/>
+          </a:xfrm>
+          <a:prstGeom prst="rect">
+            <a:avLst/>
+          </a:prstGeom>
+        </p:spPr>
+      </p:pic>
+      <p:sp>
+        <p:nvSpPr>
+          <p:cNvPr id="13" name="Text 9"/>
+          <p:cNvSpPr txBox="1"/>
+          <p:nvPr/>
+        </p:nvSpPr>
+        <p:spPr>
+          <a:xfrm>
+            <a:off x="4892040" y="2286000"/>
+            <a:ext cx="3657600" cy="365760"/>
+          </a:xfrm>
+          <a:prstGeom prst="rect">
+            <a:avLst/>
+          </a:prstGeom>
+          <a:noFill/>
+          <a:ln/>
+        </p:spPr>
+        <p:txBody>
+          <a:bodyPr wrap="square" lIns="0" tIns="0" rIns="0" bIns="0" rtlCol="0" anchor="ctr"/>
+          <a:lstStyle/>
+          <a:p>
+            <a:pPr indent="0" marL="0">
+              <a:buNone/>
+            </a:pPr>
+            <a:r>
+              <a:rPr lang="en-US" sz="1900" b="1" dirty="0">
+                <a:solidFill>
+                  <a:srgbClr val="166534"/>
+                </a:solidFill>
+                <a:latin typeface="Calibri" pitchFamily="34" charset="0"/>
+                <a:ea typeface="Calibri" pitchFamily="34" charset="-122"/>
+                <a:cs typeface="Calibri" pitchFamily="34" charset="-120"/>
+              </a:rPr>
+              <a:t>Disposable compute</a:t>
+            </a:r>
+            <a:endParaRPr lang="en-US" sz="1900" dirty="0"/>
+          </a:p>
+        </p:txBody>
+      </p:sp>
+      <p:sp>
+        <p:nvSpPr>
+          <p:cNvPr id="14" name="Text 10"/>
+          <p:cNvSpPr txBox="1"/>
+          <p:nvPr/>
+        </p:nvSpPr>
+        <p:spPr>
+          <a:xfrm>
+            <a:off x="4892040" y="2633472"/>
+            <a:ext cx="3657600" cy="365760"/>
+          </a:xfrm>
+          <a:prstGeom prst="rect">
+            <a:avLst/>
+          </a:prstGeom>
+          <a:noFill/>
+          <a:ln/>
+        </p:spPr>
+        <p:txBody>
+          <a:bodyPr wrap="square" lIns="0" tIns="0" rIns="0" bIns="0" rtlCol="0" anchor="ctr"/>
+          <a:lstStyle/>
+          <a:p>
+            <a:pPr indent="0" marL="0">
+              <a:buNone/>
+            </a:pPr>
+            <a:r>
+              <a:rPr lang="en-US" sz="1900" b="1" dirty="0">
+                <a:solidFill>
+                  <a:srgbClr val="166534"/>
+                </a:solidFill>
+                <a:latin typeface="Calibri" pitchFamily="34" charset="0"/>
+                <a:ea typeface="Calibri" pitchFamily="34" charset="-122"/>
+                <a:cs typeface="Calibri" pitchFamily="34" charset="-120"/>
+              </a:rPr>
+              <a:t>you don't have to own</a:t>
+            </a:r>
+            <a:endParaRPr lang="en-US" sz="1900" dirty="0"/>
+          </a:p>
+        </p:txBody>
+      </p:sp>
+      <p:sp>
+        <p:nvSpPr>
+          <p:cNvPr id="15" name="Text 11"/>
+          <p:cNvSpPr txBox="1"/>
+          <p:nvPr/>
+        </p:nvSpPr>
+        <p:spPr>
+          <a:xfrm>
+            <a:off x="4892040" y="3108960"/>
+            <a:ext cx="3657600" cy="1051560"/>
+          </a:xfrm>
+          <a:prstGeom prst="rect">
+            <a:avLst/>
+          </a:prstGeom>
+          <a:noFill/>
+          <a:ln/>
+        </p:spPr>
+        <p:txBody>
+          <a:bodyPr wrap="square" lIns="0" tIns="0" rIns="0" bIns="0" rtlCol="0" anchor="t"/>
+          <a:lstStyle/>
+          <a:p>
+            <a:pPr indent="0" marL="0">
+              <a:buNone/>
+            </a:pPr>
+            <a:r>
+              <a:rPr lang="en-US" sz="1300" dirty="0">
+                <a:solidFill>
+                  <a:srgbClr val="14532D"/>
+                </a:solidFill>
+                <a:latin typeface="Calibri" pitchFamily="34" charset="0"/>
+                <a:ea typeface="Calibri" pitchFamily="34" charset="-122"/>
+                <a:cs typeface="Calibri" pitchFamily="34" charset="-120"/>
+              </a:rPr>
+              <a:t>Cleaning data, prototyping, teaching, automation, debugging together, all the same move: spin up a machine for as long as the task needs, then let it go.</a:t>
+            </a:r>
+            <a:endParaRPr lang="en-US" sz="1300" dirty="0"/>
+          </a:p>
+        </p:txBody>
+      </p:sp>
+    </p:spTree>
+  </p:cSld>
+  <p:clrMapOvr>
+    <a:masterClrMapping/>
+  </p:clrMapOvr>
+</p:sld>
+</file>
+
+<file path=ppt/slides/slide6.xml><?xml version="1.0" encoding="utf-8"?>
+<p:sld xmlns:a="http://schemas.openxmlformats.org/drawingml/2006/main" xmlns:r="http://schemas.openxmlformats.org/officeDocument/2006/relationships" xmlns:p="http://schemas.openxmlformats.org/presentationml/2006/main">
+  <p:cSld name="Slide 6">
     <p:bg>
       <p:bgPr>
         <a:solidFill>

</xml_diff>